<commit_message>
leaderboard: group squares 9px → 10px
</commit_message>
<xml_diff>
--- a/WC2026_Pool_Intro.pptx
+++ b/WC2026_Pool_Intro.pptx
@@ -1856,27 +1856,7 @@
       </p:grpSpPr>
       <p:sp>
         <p:nvSpPr>
-          <p:cNvPr id="2" name="Shape 0"/>
-          <p:cNvSpPr/>
-          <p:nvPr/>
-        </p:nvSpPr>
-        <p:spPr>
-          <a:xfrm>
-            <a:off x="0" y="0"/>
-            <a:ext cx="9144000" cy="137160"/>
-          </a:xfrm>
-          <a:prstGeom prst="rect">
-            <a:avLst/>
-          </a:prstGeom>
-          <a:solidFill>
-            <a:srgbClr val="FF9E16"/>
-          </a:solidFill>
-          <a:ln/>
-        </p:spPr>
-      </p:sp>
-      <p:sp>
-        <p:nvSpPr>
-          <p:cNvPr id="3" name="Text 1"/>
+          <p:cNvPr id="2" name="Text 0"/>
           <p:cNvSpPr/>
           <p:nvPr/>
         </p:nvSpPr>
@@ -1915,7 +1895,7 @@
       </p:sp>
       <p:sp>
         <p:nvSpPr>
-          <p:cNvPr id="4" name="Text 2"/>
+          <p:cNvPr id="3" name="Text 1"/>
           <p:cNvSpPr/>
           <p:nvPr/>
         </p:nvSpPr>
@@ -1954,7 +1934,7 @@
       </p:sp>
       <p:sp>
         <p:nvSpPr>
-          <p:cNvPr id="5" name="Shape 3"/>
+          <p:cNvPr id="4" name="Shape 2"/>
           <p:cNvSpPr/>
           <p:nvPr/>
         </p:nvSpPr>
@@ -1974,7 +1954,7 @@
       </p:sp>
       <p:sp>
         <p:nvSpPr>
-          <p:cNvPr id="6" name="Text 4"/>
+          <p:cNvPr id="5" name="Text 3"/>
           <p:cNvSpPr/>
           <p:nvPr/>
         </p:nvSpPr>
@@ -2013,7 +1993,7 @@
       </p:sp>
       <p:sp>
         <p:nvSpPr>
-          <p:cNvPr id="7" name="Text 5"/>
+          <p:cNvPr id="6" name="Text 4"/>
           <p:cNvSpPr/>
           <p:nvPr/>
         </p:nvSpPr>
@@ -2084,47 +2064,7 @@
       </p:grpSpPr>
       <p:sp>
         <p:nvSpPr>
-          <p:cNvPr id="2" name="Shape 0"/>
-          <p:cNvSpPr/>
-          <p:nvPr/>
-        </p:nvSpPr>
-        <p:spPr>
-          <a:xfrm>
-            <a:off x="0" y="0"/>
-            <a:ext cx="9144000" cy="137160"/>
-          </a:xfrm>
-          <a:prstGeom prst="rect">
-            <a:avLst/>
-          </a:prstGeom>
-          <a:solidFill>
-            <a:srgbClr val="FF9E16"/>
-          </a:solidFill>
-          <a:ln/>
-        </p:spPr>
-      </p:sp>
-      <p:sp>
-        <p:nvSpPr>
-          <p:cNvPr id="3" name="Shape 1"/>
-          <p:cNvSpPr/>
-          <p:nvPr/>
-        </p:nvSpPr>
-        <p:spPr>
-          <a:xfrm>
-            <a:off x="0" y="0"/>
-            <a:ext cx="164592" cy="5143500"/>
-          </a:xfrm>
-          <a:prstGeom prst="rect">
-            <a:avLst/>
-          </a:prstGeom>
-          <a:solidFill>
-            <a:srgbClr val="009EDF"/>
-          </a:solidFill>
-          <a:ln/>
-        </p:spPr>
-      </p:sp>
-      <p:sp>
-        <p:nvSpPr>
-          <p:cNvPr id="4" name="Text 2"/>
+          <p:cNvPr id="2" name="Text 0"/>
           <p:cNvSpPr/>
           <p:nvPr/>
         </p:nvSpPr>
@@ -2163,7 +2103,7 @@
       </p:sp>
       <p:sp>
         <p:nvSpPr>
-          <p:cNvPr id="5" name="Shape 3"/>
+          <p:cNvPr id="3" name="Shape 1"/>
           <p:cNvSpPr/>
           <p:nvPr/>
         </p:nvSpPr>
@@ -2183,7 +2123,7 @@
       </p:sp>
       <p:sp>
         <p:nvSpPr>
-          <p:cNvPr id="6" name="Text 4"/>
+          <p:cNvPr id="4" name="Text 2"/>
           <p:cNvSpPr/>
           <p:nvPr/>
         </p:nvSpPr>
@@ -2222,7 +2162,7 @@
       </p:sp>
       <p:sp>
         <p:nvSpPr>
-          <p:cNvPr id="7" name="Shape 5"/>
+          <p:cNvPr id="5" name="Shape 3"/>
           <p:cNvSpPr/>
           <p:nvPr/>
         </p:nvSpPr>
@@ -2254,7 +2194,7 @@
       </p:sp>
       <p:sp>
         <p:nvSpPr>
-          <p:cNvPr id="8" name="Text 6"/>
+          <p:cNvPr id="6" name="Text 4"/>
           <p:cNvSpPr/>
           <p:nvPr/>
         </p:nvSpPr>
@@ -2293,7 +2233,7 @@
       </p:sp>
       <p:sp>
         <p:nvSpPr>
-          <p:cNvPr id="9" name="Text 7"/>
+          <p:cNvPr id="7" name="Text 5"/>
           <p:cNvSpPr/>
           <p:nvPr/>
         </p:nvSpPr>
@@ -2332,7 +2272,7 @@
       </p:sp>
       <p:sp>
         <p:nvSpPr>
-          <p:cNvPr id="10" name="Shape 8"/>
+          <p:cNvPr id="8" name="Shape 6"/>
           <p:cNvSpPr/>
           <p:nvPr/>
         </p:nvSpPr>
@@ -2364,7 +2304,7 @@
       </p:sp>
       <p:sp>
         <p:nvSpPr>
-          <p:cNvPr id="11" name="Text 9"/>
+          <p:cNvPr id="9" name="Text 7"/>
           <p:cNvSpPr/>
           <p:nvPr/>
         </p:nvSpPr>
@@ -2403,7 +2343,7 @@
       </p:sp>
       <p:sp>
         <p:nvSpPr>
-          <p:cNvPr id="12" name="Text 10"/>
+          <p:cNvPr id="10" name="Text 8"/>
           <p:cNvSpPr/>
           <p:nvPr/>
         </p:nvSpPr>
@@ -2442,7 +2382,7 @@
       </p:sp>
       <p:sp>
         <p:nvSpPr>
-          <p:cNvPr id="13" name="Shape 11"/>
+          <p:cNvPr id="11" name="Shape 9"/>
           <p:cNvSpPr/>
           <p:nvPr/>
         </p:nvSpPr>
@@ -2474,7 +2414,7 @@
       </p:sp>
       <p:sp>
         <p:nvSpPr>
-          <p:cNvPr id="14" name="Text 12"/>
+          <p:cNvPr id="12" name="Text 10"/>
           <p:cNvSpPr/>
           <p:nvPr/>
         </p:nvSpPr>
@@ -2513,7 +2453,7 @@
       </p:sp>
       <p:sp>
         <p:nvSpPr>
-          <p:cNvPr id="15" name="Text 13"/>
+          <p:cNvPr id="13" name="Text 11"/>
           <p:cNvSpPr/>
           <p:nvPr/>
         </p:nvSpPr>
@@ -2552,7 +2492,7 @@
       </p:sp>
       <p:sp>
         <p:nvSpPr>
-          <p:cNvPr id="16" name="Text 14"/>
+          <p:cNvPr id="14" name="Text 12"/>
           <p:cNvSpPr/>
           <p:nvPr/>
         </p:nvSpPr>
@@ -2591,7 +2531,7 @@
       </p:sp>
       <p:sp>
         <p:nvSpPr>
-          <p:cNvPr id="17" name="Shape 15"/>
+          <p:cNvPr id="15" name="Shape 13"/>
           <p:cNvSpPr/>
           <p:nvPr/>
         </p:nvSpPr>
@@ -2623,7 +2563,7 @@
       </p:sp>
       <p:sp>
         <p:nvSpPr>
-          <p:cNvPr id="18" name="Text 16"/>
+          <p:cNvPr id="16" name="Text 14"/>
           <p:cNvSpPr/>
           <p:nvPr/>
         </p:nvSpPr>
@@ -2662,7 +2602,7 @@
       </p:sp>
       <p:sp>
         <p:nvSpPr>
-          <p:cNvPr id="19" name="Shape 17"/>
+          <p:cNvPr id="17" name="Shape 15"/>
           <p:cNvSpPr/>
           <p:nvPr/>
         </p:nvSpPr>
@@ -2694,7 +2634,7 @@
       </p:sp>
       <p:sp>
         <p:nvSpPr>
-          <p:cNvPr id="20" name="Text 18"/>
+          <p:cNvPr id="18" name="Text 16"/>
           <p:cNvSpPr/>
           <p:nvPr/>
         </p:nvSpPr>
@@ -2733,7 +2673,7 @@
       </p:sp>
       <p:sp>
         <p:nvSpPr>
-          <p:cNvPr id="21" name="Text 19"/>
+          <p:cNvPr id="19" name="Text 17"/>
           <p:cNvSpPr/>
           <p:nvPr/>
         </p:nvSpPr>
@@ -2772,7 +2712,7 @@
       </p:sp>
       <p:sp>
         <p:nvSpPr>
-          <p:cNvPr id="22" name="Shape 20"/>
+          <p:cNvPr id="20" name="Shape 18"/>
           <p:cNvSpPr/>
           <p:nvPr/>
         </p:nvSpPr>
@@ -2797,7 +2737,7 @@
       </p:sp>
       <p:sp>
         <p:nvSpPr>
-          <p:cNvPr id="23" name="Text 21"/>
+          <p:cNvPr id="21" name="Text 19"/>
           <p:cNvSpPr/>
           <p:nvPr/>
         </p:nvSpPr>
@@ -2836,7 +2776,7 @@
       </p:sp>
       <p:sp>
         <p:nvSpPr>
-          <p:cNvPr id="24" name="Text 22"/>
+          <p:cNvPr id="22" name="Text 20"/>
           <p:cNvSpPr/>
           <p:nvPr/>
         </p:nvSpPr>
@@ -2875,7 +2815,7 @@
       </p:sp>
       <p:sp>
         <p:nvSpPr>
-          <p:cNvPr id="25" name="Shape 23"/>
+          <p:cNvPr id="23" name="Shape 21"/>
           <p:cNvSpPr/>
           <p:nvPr/>
         </p:nvSpPr>
@@ -2900,7 +2840,7 @@
       </p:sp>
       <p:sp>
         <p:nvSpPr>
-          <p:cNvPr id="26" name="Text 24"/>
+          <p:cNvPr id="24" name="Text 22"/>
           <p:cNvSpPr/>
           <p:nvPr/>
         </p:nvSpPr>
@@ -2939,7 +2879,7 @@
       </p:sp>
       <p:sp>
         <p:nvSpPr>
-          <p:cNvPr id="27" name="Text 25"/>
+          <p:cNvPr id="25" name="Text 23"/>
           <p:cNvSpPr/>
           <p:nvPr/>
         </p:nvSpPr>
@@ -2978,7 +2918,7 @@
       </p:sp>
       <p:sp>
         <p:nvSpPr>
-          <p:cNvPr id="28" name="Shape 26"/>
+          <p:cNvPr id="26" name="Shape 24"/>
           <p:cNvSpPr/>
           <p:nvPr/>
         </p:nvSpPr>
@@ -3003,7 +2943,7 @@
       </p:sp>
       <p:sp>
         <p:nvSpPr>
-          <p:cNvPr id="29" name="Text 27"/>
+          <p:cNvPr id="27" name="Text 25"/>
           <p:cNvSpPr/>
           <p:nvPr/>
         </p:nvSpPr>
@@ -3042,7 +2982,7 @@
       </p:sp>
       <p:sp>
         <p:nvSpPr>
-          <p:cNvPr id="30" name="Shape 28"/>
+          <p:cNvPr id="28" name="Shape 26"/>
           <p:cNvSpPr/>
           <p:nvPr/>
         </p:nvSpPr>
@@ -3062,7 +3002,7 @@
       </p:sp>
       <p:sp>
         <p:nvSpPr>
-          <p:cNvPr id="31" name="Text 29"/>
+          <p:cNvPr id="29" name="Text 27"/>
           <p:cNvSpPr/>
           <p:nvPr/>
         </p:nvSpPr>
@@ -3101,7 +3041,7 @@
       </p:sp>
       <p:sp>
         <p:nvSpPr>
-          <p:cNvPr id="32" name="Shape 30"/>
+          <p:cNvPr id="30" name="Shape 28"/>
           <p:cNvSpPr/>
           <p:nvPr/>
         </p:nvSpPr>
@@ -3126,7 +3066,7 @@
       </p:sp>
       <p:sp>
         <p:nvSpPr>
-          <p:cNvPr id="33" name="Text 31"/>
+          <p:cNvPr id="31" name="Text 29"/>
           <p:cNvSpPr/>
           <p:nvPr/>
         </p:nvSpPr>
@@ -3165,7 +3105,7 @@
       </p:sp>
       <p:sp>
         <p:nvSpPr>
-          <p:cNvPr id="34" name="Shape 32"/>
+          <p:cNvPr id="32" name="Shape 30"/>
           <p:cNvSpPr/>
           <p:nvPr/>
         </p:nvSpPr>
@@ -3185,7 +3125,7 @@
       </p:sp>
       <p:sp>
         <p:nvSpPr>
-          <p:cNvPr id="35" name="Text 33"/>
+          <p:cNvPr id="33" name="Text 31"/>
           <p:cNvSpPr/>
           <p:nvPr/>
         </p:nvSpPr>
@@ -3256,47 +3196,7 @@
       </p:grpSpPr>
       <p:sp>
         <p:nvSpPr>
-          <p:cNvPr id="2" name="Shape 0"/>
-          <p:cNvSpPr/>
-          <p:nvPr/>
-        </p:nvSpPr>
-        <p:spPr>
-          <a:xfrm>
-            <a:off x="0" y="0"/>
-            <a:ext cx="9144000" cy="137160"/>
-          </a:xfrm>
-          <a:prstGeom prst="rect">
-            <a:avLst/>
-          </a:prstGeom>
-          <a:solidFill>
-            <a:srgbClr val="FF9E16"/>
-          </a:solidFill>
-          <a:ln/>
-        </p:spPr>
-      </p:sp>
-      <p:sp>
-        <p:nvSpPr>
-          <p:cNvPr id="3" name="Shape 1"/>
-          <p:cNvSpPr/>
-          <p:nvPr/>
-        </p:nvSpPr>
-        <p:spPr>
-          <a:xfrm>
-            <a:off x="0" y="0"/>
-            <a:ext cx="164592" cy="5143500"/>
-          </a:xfrm>
-          <a:prstGeom prst="rect">
-            <a:avLst/>
-          </a:prstGeom>
-          <a:solidFill>
-            <a:srgbClr val="009EDF"/>
-          </a:solidFill>
-          <a:ln/>
-        </p:spPr>
-      </p:sp>
-      <p:sp>
-        <p:nvSpPr>
-          <p:cNvPr id="4" name="Text 2"/>
+          <p:cNvPr id="2" name="Text 0"/>
           <p:cNvSpPr/>
           <p:nvPr/>
         </p:nvSpPr>
@@ -3335,7 +3235,7 @@
       </p:sp>
       <p:sp>
         <p:nvSpPr>
-          <p:cNvPr id="5" name="Shape 3"/>
+          <p:cNvPr id="3" name="Shape 1"/>
           <p:cNvSpPr/>
           <p:nvPr/>
         </p:nvSpPr>
@@ -3355,7 +3255,7 @@
       </p:sp>
       <p:sp>
         <p:nvSpPr>
-          <p:cNvPr id="6" name="Text 4"/>
+          <p:cNvPr id="4" name="Text 2"/>
           <p:cNvSpPr/>
           <p:nvPr/>
         </p:nvSpPr>
@@ -3394,7 +3294,7 @@
       </p:sp>
       <p:sp>
         <p:nvSpPr>
-          <p:cNvPr id="7" name="Shape 5"/>
+          <p:cNvPr id="5" name="Shape 3"/>
           <p:cNvSpPr/>
           <p:nvPr/>
         </p:nvSpPr>
@@ -3426,7 +3326,7 @@
       </p:sp>
       <p:sp>
         <p:nvSpPr>
-          <p:cNvPr id="8" name="Shape 6"/>
+          <p:cNvPr id="6" name="Shape 4"/>
           <p:cNvSpPr/>
           <p:nvPr/>
         </p:nvSpPr>
@@ -3446,7 +3346,7 @@
       </p:sp>
       <p:sp>
         <p:nvSpPr>
-          <p:cNvPr id="9" name="Text 7"/>
+          <p:cNvPr id="7" name="Text 5"/>
           <p:cNvSpPr/>
           <p:nvPr/>
         </p:nvSpPr>
@@ -3485,7 +3385,7 @@
       </p:sp>
       <p:sp>
         <p:nvSpPr>
-          <p:cNvPr id="10" name="Text 8"/>
+          <p:cNvPr id="8" name="Text 6"/>
           <p:cNvSpPr/>
           <p:nvPr/>
         </p:nvSpPr>
@@ -3524,7 +3424,7 @@
       </p:sp>
       <p:sp>
         <p:nvSpPr>
-          <p:cNvPr id="11" name="Shape 9"/>
+          <p:cNvPr id="9" name="Shape 7"/>
           <p:cNvSpPr/>
           <p:nvPr/>
         </p:nvSpPr>
@@ -3544,7 +3444,7 @@
       </p:sp>
       <p:sp>
         <p:nvSpPr>
-          <p:cNvPr id="12" name="Shape 10"/>
+          <p:cNvPr id="10" name="Shape 8"/>
           <p:cNvSpPr/>
           <p:nvPr/>
         </p:nvSpPr>
@@ -3564,7 +3464,7 @@
       </p:sp>
       <p:sp>
         <p:nvSpPr>
-          <p:cNvPr id="13" name="Text 11"/>
+          <p:cNvPr id="11" name="Text 9"/>
           <p:cNvSpPr/>
           <p:nvPr/>
         </p:nvSpPr>
@@ -3603,7 +3503,7 @@
       </p:sp>
       <p:sp>
         <p:nvSpPr>
-          <p:cNvPr id="14" name="Shape 12"/>
+          <p:cNvPr id="12" name="Shape 10"/>
           <p:cNvSpPr/>
           <p:nvPr/>
         </p:nvSpPr>
@@ -3623,7 +3523,7 @@
       </p:sp>
       <p:sp>
         <p:nvSpPr>
-          <p:cNvPr id="15" name="Text 13"/>
+          <p:cNvPr id="13" name="Text 11"/>
           <p:cNvSpPr/>
           <p:nvPr/>
         </p:nvSpPr>
@@ -3662,7 +3562,7 @@
       </p:sp>
       <p:sp>
         <p:nvSpPr>
-          <p:cNvPr id="16" name="Shape 14"/>
+          <p:cNvPr id="14" name="Shape 12"/>
           <p:cNvSpPr/>
           <p:nvPr/>
         </p:nvSpPr>
@@ -3682,7 +3582,7 @@
       </p:sp>
       <p:sp>
         <p:nvSpPr>
-          <p:cNvPr id="17" name="Shape 15"/>
+          <p:cNvPr id="15" name="Shape 13"/>
           <p:cNvSpPr/>
           <p:nvPr/>
         </p:nvSpPr>
@@ -3702,7 +3602,7 @@
       </p:sp>
       <p:sp>
         <p:nvSpPr>
-          <p:cNvPr id="18" name="Text 16"/>
+          <p:cNvPr id="16" name="Text 14"/>
           <p:cNvSpPr/>
           <p:nvPr/>
         </p:nvSpPr>
@@ -3741,7 +3641,7 @@
       </p:sp>
       <p:sp>
         <p:nvSpPr>
-          <p:cNvPr id="19" name="Shape 17"/>
+          <p:cNvPr id="17" name="Shape 15"/>
           <p:cNvSpPr/>
           <p:nvPr/>
         </p:nvSpPr>
@@ -3761,7 +3661,7 @@
       </p:sp>
       <p:sp>
         <p:nvSpPr>
-          <p:cNvPr id="20" name="Text 18"/>
+          <p:cNvPr id="18" name="Text 16"/>
           <p:cNvSpPr/>
           <p:nvPr/>
         </p:nvSpPr>
@@ -3800,7 +3700,7 @@
       </p:sp>
       <p:sp>
         <p:nvSpPr>
-          <p:cNvPr id="21" name="Shape 19"/>
+          <p:cNvPr id="19" name="Shape 17"/>
           <p:cNvSpPr/>
           <p:nvPr/>
         </p:nvSpPr>
@@ -3820,7 +3720,7 @@
       </p:sp>
       <p:sp>
         <p:nvSpPr>
-          <p:cNvPr id="22" name="Shape 20"/>
+          <p:cNvPr id="20" name="Shape 18"/>
           <p:cNvSpPr/>
           <p:nvPr/>
         </p:nvSpPr>
@@ -3840,7 +3740,7 @@
       </p:sp>
       <p:sp>
         <p:nvSpPr>
-          <p:cNvPr id="23" name="Text 21"/>
+          <p:cNvPr id="21" name="Text 19"/>
           <p:cNvSpPr/>
           <p:nvPr/>
         </p:nvSpPr>
@@ -3879,7 +3779,7 @@
       </p:sp>
       <p:sp>
         <p:nvSpPr>
-          <p:cNvPr id="24" name="Shape 22"/>
+          <p:cNvPr id="22" name="Shape 20"/>
           <p:cNvSpPr/>
           <p:nvPr/>
         </p:nvSpPr>
@@ -3899,7 +3799,7 @@
       </p:sp>
       <p:sp>
         <p:nvSpPr>
-          <p:cNvPr id="25" name="Text 23"/>
+          <p:cNvPr id="23" name="Text 21"/>
           <p:cNvSpPr/>
           <p:nvPr/>
         </p:nvSpPr>
@@ -3938,7 +3838,7 @@
       </p:sp>
       <p:sp>
         <p:nvSpPr>
-          <p:cNvPr id="26" name="Shape 24"/>
+          <p:cNvPr id="24" name="Shape 22"/>
           <p:cNvSpPr/>
           <p:nvPr/>
         </p:nvSpPr>
@@ -3958,7 +3858,7 @@
       </p:sp>
       <p:sp>
         <p:nvSpPr>
-          <p:cNvPr id="27" name="Shape 25"/>
+          <p:cNvPr id="25" name="Shape 23"/>
           <p:cNvSpPr/>
           <p:nvPr/>
         </p:nvSpPr>
@@ -3978,7 +3878,7 @@
       </p:sp>
       <p:sp>
         <p:nvSpPr>
-          <p:cNvPr id="28" name="Text 26"/>
+          <p:cNvPr id="26" name="Text 24"/>
           <p:cNvSpPr/>
           <p:nvPr/>
         </p:nvSpPr>
@@ -4017,7 +3917,7 @@
       </p:sp>
       <p:sp>
         <p:nvSpPr>
-          <p:cNvPr id="29" name="Shape 27"/>
+          <p:cNvPr id="27" name="Shape 25"/>
           <p:cNvSpPr/>
           <p:nvPr/>
         </p:nvSpPr>
@@ -4037,7 +3937,7 @@
       </p:sp>
       <p:sp>
         <p:nvSpPr>
-          <p:cNvPr id="30" name="Text 28"/>
+          <p:cNvPr id="28" name="Text 26"/>
           <p:cNvSpPr/>
           <p:nvPr/>
         </p:nvSpPr>
@@ -4076,7 +3976,7 @@
       </p:sp>
       <p:sp>
         <p:nvSpPr>
-          <p:cNvPr id="31" name="Shape 29"/>
+          <p:cNvPr id="29" name="Shape 27"/>
           <p:cNvSpPr/>
           <p:nvPr/>
         </p:nvSpPr>
@@ -4096,7 +3996,7 @@
       </p:sp>
       <p:sp>
         <p:nvSpPr>
-          <p:cNvPr id="32" name="Shape 30"/>
+          <p:cNvPr id="30" name="Shape 28"/>
           <p:cNvSpPr/>
           <p:nvPr/>
         </p:nvSpPr>
@@ -4116,7 +4016,7 @@
       </p:sp>
       <p:sp>
         <p:nvSpPr>
-          <p:cNvPr id="33" name="Text 31"/>
+          <p:cNvPr id="31" name="Text 29"/>
           <p:cNvSpPr/>
           <p:nvPr/>
         </p:nvSpPr>
@@ -4155,7 +4055,7 @@
       </p:sp>
       <p:sp>
         <p:nvSpPr>
-          <p:cNvPr id="34" name="Shape 32"/>
+          <p:cNvPr id="32" name="Shape 30"/>
           <p:cNvSpPr/>
           <p:nvPr/>
         </p:nvSpPr>
@@ -4175,7 +4075,7 @@
       </p:sp>
       <p:sp>
         <p:nvSpPr>
-          <p:cNvPr id="35" name="Text 33"/>
+          <p:cNvPr id="33" name="Text 31"/>
           <p:cNvSpPr/>
           <p:nvPr/>
         </p:nvSpPr>
@@ -4214,7 +4114,7 @@
       </p:sp>
       <p:sp>
         <p:nvSpPr>
-          <p:cNvPr id="36" name="Shape 34"/>
+          <p:cNvPr id="34" name="Shape 32"/>
           <p:cNvSpPr/>
           <p:nvPr/>
         </p:nvSpPr>
@@ -4234,7 +4134,7 @@
       </p:sp>
       <p:sp>
         <p:nvSpPr>
-          <p:cNvPr id="37" name="Shape 35"/>
+          <p:cNvPr id="35" name="Shape 33"/>
           <p:cNvSpPr/>
           <p:nvPr/>
         </p:nvSpPr>
@@ -4254,7 +4154,7 @@
       </p:sp>
       <p:sp>
         <p:nvSpPr>
-          <p:cNvPr id="38" name="Text 36"/>
+          <p:cNvPr id="36" name="Text 34"/>
           <p:cNvSpPr/>
           <p:nvPr/>
         </p:nvSpPr>
@@ -4293,7 +4193,7 @@
       </p:sp>
       <p:sp>
         <p:nvSpPr>
-          <p:cNvPr id="39" name="Shape 37"/>
+          <p:cNvPr id="37" name="Shape 35"/>
           <p:cNvSpPr/>
           <p:nvPr/>
         </p:nvSpPr>
@@ -4313,7 +4213,7 @@
       </p:sp>
       <p:sp>
         <p:nvSpPr>
-          <p:cNvPr id="40" name="Text 38"/>
+          <p:cNvPr id="38" name="Text 36"/>
           <p:cNvSpPr/>
           <p:nvPr/>
         </p:nvSpPr>
@@ -4352,7 +4252,7 @@
       </p:sp>
       <p:sp>
         <p:nvSpPr>
-          <p:cNvPr id="41" name="Shape 39"/>
+          <p:cNvPr id="39" name="Shape 37"/>
           <p:cNvSpPr/>
           <p:nvPr/>
         </p:nvSpPr>
@@ -4372,7 +4272,7 @@
       </p:sp>
       <p:sp>
         <p:nvSpPr>
-          <p:cNvPr id="42" name="Text 40"/>
+          <p:cNvPr id="40" name="Text 38"/>
           <p:cNvSpPr/>
           <p:nvPr/>
         </p:nvSpPr>
@@ -4411,7 +4311,7 @@
       </p:sp>
       <p:sp>
         <p:nvSpPr>
-          <p:cNvPr id="43" name="Text 41"/>
+          <p:cNvPr id="41" name="Text 39"/>
           <p:cNvSpPr/>
           <p:nvPr/>
         </p:nvSpPr>
@@ -4450,7 +4350,7 @@
       </p:sp>
       <p:sp>
         <p:nvSpPr>
-          <p:cNvPr id="44" name="Shape 42"/>
+          <p:cNvPr id="42" name="Shape 40"/>
           <p:cNvSpPr/>
           <p:nvPr/>
         </p:nvSpPr>
@@ -4482,7 +4382,7 @@
       </p:sp>
       <p:sp>
         <p:nvSpPr>
-          <p:cNvPr id="45" name="Shape 43"/>
+          <p:cNvPr id="43" name="Shape 41"/>
           <p:cNvSpPr/>
           <p:nvPr/>
         </p:nvSpPr>
@@ -4502,7 +4402,7 @@
       </p:sp>
       <p:sp>
         <p:nvSpPr>
-          <p:cNvPr id="46" name="Text 44"/>
+          <p:cNvPr id="44" name="Text 42"/>
           <p:cNvSpPr/>
           <p:nvPr/>
         </p:nvSpPr>
@@ -4541,7 +4441,7 @@
       </p:sp>
       <p:sp>
         <p:nvSpPr>
-          <p:cNvPr id="47" name="Text 45"/>
+          <p:cNvPr id="45" name="Text 43"/>
           <p:cNvSpPr/>
           <p:nvPr/>
         </p:nvSpPr>
@@ -4580,7 +4480,7 @@
       </p:sp>
       <p:sp>
         <p:nvSpPr>
-          <p:cNvPr id="48" name="Shape 46"/>
+          <p:cNvPr id="46" name="Shape 44"/>
           <p:cNvSpPr/>
           <p:nvPr/>
         </p:nvSpPr>
@@ -4605,7 +4505,7 @@
       </p:sp>
       <p:sp>
         <p:nvSpPr>
-          <p:cNvPr id="49" name="Shape 47"/>
+          <p:cNvPr id="47" name="Shape 45"/>
           <p:cNvSpPr/>
           <p:nvPr/>
         </p:nvSpPr>
@@ -4625,7 +4525,7 @@
       </p:sp>
       <p:sp>
         <p:nvSpPr>
-          <p:cNvPr id="50" name="Text 48"/>
+          <p:cNvPr id="48" name="Text 46"/>
           <p:cNvSpPr/>
           <p:nvPr/>
         </p:nvSpPr>
@@ -4664,7 +4564,7 @@
       </p:sp>
       <p:sp>
         <p:nvSpPr>
-          <p:cNvPr id="51" name="Text 49"/>
+          <p:cNvPr id="49" name="Text 47"/>
           <p:cNvSpPr/>
           <p:nvPr/>
         </p:nvSpPr>
@@ -4703,7 +4603,7 @@
       </p:sp>
       <p:sp>
         <p:nvSpPr>
-          <p:cNvPr id="52" name="Text 50"/>
+          <p:cNvPr id="50" name="Text 48"/>
           <p:cNvSpPr/>
           <p:nvPr/>
         </p:nvSpPr>
@@ -4742,7 +4642,7 @@
       </p:sp>
       <p:sp>
         <p:nvSpPr>
-          <p:cNvPr id="53" name="Text 51"/>
+          <p:cNvPr id="51" name="Text 49"/>
           <p:cNvSpPr/>
           <p:nvPr/>
         </p:nvSpPr>
@@ -4781,7 +4681,7 @@
       </p:sp>
       <p:sp>
         <p:nvSpPr>
-          <p:cNvPr id="54" name="Shape 52"/>
+          <p:cNvPr id="52" name="Shape 50"/>
           <p:cNvSpPr/>
           <p:nvPr/>
         </p:nvSpPr>
@@ -4806,7 +4706,7 @@
       </p:sp>
       <p:sp>
         <p:nvSpPr>
-          <p:cNvPr id="55" name="Shape 53"/>
+          <p:cNvPr id="53" name="Shape 51"/>
           <p:cNvSpPr/>
           <p:nvPr/>
         </p:nvSpPr>
@@ -4826,7 +4726,7 @@
       </p:sp>
       <p:sp>
         <p:nvSpPr>
-          <p:cNvPr id="56" name="Text 54"/>
+          <p:cNvPr id="54" name="Text 52"/>
           <p:cNvSpPr/>
           <p:nvPr/>
         </p:nvSpPr>
@@ -4865,7 +4765,7 @@
       </p:sp>
       <p:sp>
         <p:nvSpPr>
-          <p:cNvPr id="57" name="Text 55"/>
+          <p:cNvPr id="55" name="Text 53"/>
           <p:cNvSpPr/>
           <p:nvPr/>
         </p:nvSpPr>
@@ -4904,7 +4804,7 @@
       </p:sp>
       <p:sp>
         <p:nvSpPr>
-          <p:cNvPr id="58" name="Text 56"/>
+          <p:cNvPr id="56" name="Text 54"/>
           <p:cNvSpPr/>
           <p:nvPr/>
         </p:nvSpPr>
@@ -4943,7 +4843,7 @@
       </p:sp>
       <p:sp>
         <p:nvSpPr>
-          <p:cNvPr id="59" name="Text 57"/>
+          <p:cNvPr id="57" name="Text 55"/>
           <p:cNvSpPr/>
           <p:nvPr/>
         </p:nvSpPr>
@@ -4982,7 +4882,7 @@
       </p:sp>
       <p:sp>
         <p:nvSpPr>
-          <p:cNvPr id="60" name="Shape 58"/>
+          <p:cNvPr id="58" name="Shape 56"/>
           <p:cNvSpPr/>
           <p:nvPr/>
         </p:nvSpPr>
@@ -5007,7 +4907,7 @@
       </p:sp>
       <p:sp>
         <p:nvSpPr>
-          <p:cNvPr id="61" name="Shape 59"/>
+          <p:cNvPr id="59" name="Shape 57"/>
           <p:cNvSpPr/>
           <p:nvPr/>
         </p:nvSpPr>
@@ -5027,7 +4927,7 @@
       </p:sp>
       <p:sp>
         <p:nvSpPr>
-          <p:cNvPr id="62" name="Text 60"/>
+          <p:cNvPr id="60" name="Text 58"/>
           <p:cNvSpPr/>
           <p:nvPr/>
         </p:nvSpPr>
@@ -5066,7 +4966,7 @@
       </p:sp>
       <p:sp>
         <p:nvSpPr>
-          <p:cNvPr id="63" name="Text 61"/>
+          <p:cNvPr id="61" name="Text 59"/>
           <p:cNvSpPr/>
           <p:nvPr/>
         </p:nvSpPr>
@@ -5105,7 +5005,7 @@
       </p:sp>
       <p:sp>
         <p:nvSpPr>
-          <p:cNvPr id="64" name="Text 62"/>
+          <p:cNvPr id="62" name="Text 60"/>
           <p:cNvSpPr/>
           <p:nvPr/>
         </p:nvSpPr>
@@ -5144,7 +5044,7 @@
       </p:sp>
       <p:sp>
         <p:nvSpPr>
-          <p:cNvPr id="65" name="Shape 63"/>
+          <p:cNvPr id="63" name="Shape 61"/>
           <p:cNvSpPr/>
           <p:nvPr/>
         </p:nvSpPr>
@@ -5169,7 +5069,7 @@
       </p:sp>
       <p:sp>
         <p:nvSpPr>
-          <p:cNvPr id="66" name="Shape 64"/>
+          <p:cNvPr id="64" name="Shape 62"/>
           <p:cNvSpPr/>
           <p:nvPr/>
         </p:nvSpPr>
@@ -5189,7 +5089,7 @@
       </p:sp>
       <p:sp>
         <p:nvSpPr>
-          <p:cNvPr id="67" name="Text 65"/>
+          <p:cNvPr id="65" name="Text 63"/>
           <p:cNvSpPr/>
           <p:nvPr/>
         </p:nvSpPr>
@@ -5263,27 +5163,7 @@
       </p:grpSpPr>
       <p:sp>
         <p:nvSpPr>
-          <p:cNvPr id="2" name="Shape 0"/>
-          <p:cNvSpPr/>
-          <p:nvPr/>
-        </p:nvSpPr>
-        <p:spPr>
-          <a:xfrm>
-            <a:off x="0" y="0"/>
-            <a:ext cx="9144000" cy="137160"/>
-          </a:xfrm>
-          <a:prstGeom prst="rect">
-            <a:avLst/>
-          </a:prstGeom>
-          <a:solidFill>
-            <a:srgbClr val="FF9E16"/>
-          </a:solidFill>
-          <a:ln/>
-        </p:spPr>
-      </p:sp>
-      <p:sp>
-        <p:nvSpPr>
-          <p:cNvPr id="3" name="Text 1"/>
+          <p:cNvPr id="2" name="Text 0"/>
           <p:cNvSpPr/>
           <p:nvPr/>
         </p:nvSpPr>
@@ -5322,7 +5202,7 @@
       </p:sp>
       <p:sp>
         <p:nvSpPr>
-          <p:cNvPr id="4" name="Text 2"/>
+          <p:cNvPr id="3" name="Text 1"/>
           <p:cNvSpPr/>
           <p:nvPr/>
         </p:nvSpPr>
@@ -5361,7 +5241,7 @@
       </p:sp>
       <p:sp>
         <p:nvSpPr>
-          <p:cNvPr id="5" name="Shape 3"/>
+          <p:cNvPr id="4" name="Shape 2"/>
           <p:cNvSpPr/>
           <p:nvPr/>
         </p:nvSpPr>
@@ -5381,7 +5261,7 @@
       </p:sp>
       <p:sp>
         <p:nvSpPr>
-          <p:cNvPr id="6" name="Text 4"/>
+          <p:cNvPr id="5" name="Text 3"/>
           <p:cNvSpPr/>
           <p:nvPr/>
         </p:nvSpPr>
@@ -5452,47 +5332,7 @@
       </p:grpSpPr>
       <p:sp>
         <p:nvSpPr>
-          <p:cNvPr id="2" name="Shape 0"/>
-          <p:cNvSpPr/>
-          <p:nvPr/>
-        </p:nvSpPr>
-        <p:spPr>
-          <a:xfrm>
-            <a:off x="0" y="0"/>
-            <a:ext cx="9144000" cy="137160"/>
-          </a:xfrm>
-          <a:prstGeom prst="rect">
-            <a:avLst/>
-          </a:prstGeom>
-          <a:solidFill>
-            <a:srgbClr val="FF9E16"/>
-          </a:solidFill>
-          <a:ln/>
-        </p:spPr>
-      </p:sp>
-      <p:sp>
-        <p:nvSpPr>
-          <p:cNvPr id="3" name="Shape 1"/>
-          <p:cNvSpPr/>
-          <p:nvPr/>
-        </p:nvSpPr>
-        <p:spPr>
-          <a:xfrm>
-            <a:off x="0" y="0"/>
-            <a:ext cx="164592" cy="5143500"/>
-          </a:xfrm>
-          <a:prstGeom prst="rect">
-            <a:avLst/>
-          </a:prstGeom>
-          <a:solidFill>
-            <a:srgbClr val="009EDF"/>
-          </a:solidFill>
-          <a:ln/>
-        </p:spPr>
-      </p:sp>
-      <p:sp>
-        <p:nvSpPr>
-          <p:cNvPr id="4" name="Text 2"/>
+          <p:cNvPr id="2" name="Text 0"/>
           <p:cNvSpPr/>
           <p:nvPr/>
         </p:nvSpPr>
@@ -5531,7 +5371,7 @@
       </p:sp>
       <p:sp>
         <p:nvSpPr>
-          <p:cNvPr id="5" name="Shape 3"/>
+          <p:cNvPr id="3" name="Shape 1"/>
           <p:cNvSpPr/>
           <p:nvPr/>
         </p:nvSpPr>
@@ -5551,7 +5391,7 @@
       </p:sp>
       <p:sp>
         <p:nvSpPr>
-          <p:cNvPr id="6" name="Shape 4"/>
+          <p:cNvPr id="4" name="Shape 2"/>
           <p:cNvSpPr/>
           <p:nvPr/>
         </p:nvSpPr>
@@ -5583,7 +5423,7 @@
       </p:sp>
       <p:sp>
         <p:nvSpPr>
-          <p:cNvPr id="7" name="Shape 5"/>
+          <p:cNvPr id="5" name="Shape 3"/>
           <p:cNvSpPr/>
           <p:nvPr/>
         </p:nvSpPr>
@@ -5603,7 +5443,7 @@
       </p:sp>
       <p:sp>
         <p:nvSpPr>
-          <p:cNvPr id="8" name="Text 6"/>
+          <p:cNvPr id="6" name="Text 4"/>
           <p:cNvSpPr/>
           <p:nvPr/>
         </p:nvSpPr>
@@ -5642,7 +5482,7 @@
       </p:sp>
       <p:sp>
         <p:nvSpPr>
-          <p:cNvPr id="9" name="Shape 7"/>
+          <p:cNvPr id="7" name="Shape 5"/>
           <p:cNvSpPr/>
           <p:nvPr/>
         </p:nvSpPr>
@@ -5662,7 +5502,7 @@
       </p:sp>
       <p:sp>
         <p:nvSpPr>
-          <p:cNvPr id="10" name="Shape 8"/>
+          <p:cNvPr id="8" name="Shape 6"/>
           <p:cNvSpPr/>
           <p:nvPr/>
         </p:nvSpPr>
@@ -5682,7 +5522,7 @@
       </p:sp>
       <p:sp>
         <p:nvSpPr>
-          <p:cNvPr id="11" name="Text 9"/>
+          <p:cNvPr id="9" name="Text 7"/>
           <p:cNvSpPr/>
           <p:nvPr/>
         </p:nvSpPr>
@@ -5721,7 +5561,7 @@
       </p:sp>
       <p:sp>
         <p:nvSpPr>
-          <p:cNvPr id="12" name="Shape 10"/>
+          <p:cNvPr id="10" name="Shape 8"/>
           <p:cNvSpPr/>
           <p:nvPr/>
         </p:nvSpPr>
@@ -5741,7 +5581,7 @@
       </p:sp>
       <p:sp>
         <p:nvSpPr>
-          <p:cNvPr id="13" name="Text 11"/>
+          <p:cNvPr id="11" name="Text 9"/>
           <p:cNvSpPr/>
           <p:nvPr/>
         </p:nvSpPr>
@@ -5780,7 +5620,7 @@
       </p:sp>
       <p:sp>
         <p:nvSpPr>
-          <p:cNvPr id="14" name="Shape 12"/>
+          <p:cNvPr id="12" name="Shape 10"/>
           <p:cNvSpPr/>
           <p:nvPr/>
         </p:nvSpPr>
@@ -5800,7 +5640,7 @@
       </p:sp>
       <p:sp>
         <p:nvSpPr>
-          <p:cNvPr id="15" name="Shape 13"/>
+          <p:cNvPr id="13" name="Shape 11"/>
           <p:cNvSpPr/>
           <p:nvPr/>
         </p:nvSpPr>
@@ -5820,7 +5660,7 @@
       </p:sp>
       <p:sp>
         <p:nvSpPr>
-          <p:cNvPr id="16" name="Text 14"/>
+          <p:cNvPr id="14" name="Text 12"/>
           <p:cNvSpPr/>
           <p:nvPr/>
         </p:nvSpPr>
@@ -5859,7 +5699,7 @@
       </p:sp>
       <p:sp>
         <p:nvSpPr>
-          <p:cNvPr id="17" name="Shape 15"/>
+          <p:cNvPr id="15" name="Shape 13"/>
           <p:cNvSpPr/>
           <p:nvPr/>
         </p:nvSpPr>
@@ -5879,7 +5719,7 @@
       </p:sp>
       <p:sp>
         <p:nvSpPr>
-          <p:cNvPr id="18" name="Text 16"/>
+          <p:cNvPr id="16" name="Text 14"/>
           <p:cNvSpPr/>
           <p:nvPr/>
         </p:nvSpPr>
@@ -5918,7 +5758,7 @@
       </p:sp>
       <p:sp>
         <p:nvSpPr>
-          <p:cNvPr id="19" name="Shape 17"/>
+          <p:cNvPr id="17" name="Shape 15"/>
           <p:cNvSpPr/>
           <p:nvPr/>
         </p:nvSpPr>
@@ -5938,7 +5778,7 @@
       </p:sp>
       <p:sp>
         <p:nvSpPr>
-          <p:cNvPr id="20" name="Shape 18"/>
+          <p:cNvPr id="18" name="Shape 16"/>
           <p:cNvSpPr/>
           <p:nvPr/>
         </p:nvSpPr>
@@ -5958,7 +5798,7 @@
       </p:sp>
       <p:sp>
         <p:nvSpPr>
-          <p:cNvPr id="21" name="Text 19"/>
+          <p:cNvPr id="19" name="Text 17"/>
           <p:cNvSpPr/>
           <p:nvPr/>
         </p:nvSpPr>
@@ -5997,7 +5837,7 @@
       </p:sp>
       <p:sp>
         <p:nvSpPr>
-          <p:cNvPr id="22" name="Shape 20"/>
+          <p:cNvPr id="20" name="Shape 18"/>
           <p:cNvSpPr/>
           <p:nvPr/>
         </p:nvSpPr>
@@ -6017,7 +5857,7 @@
       </p:sp>
       <p:sp>
         <p:nvSpPr>
-          <p:cNvPr id="23" name="Text 21"/>
+          <p:cNvPr id="21" name="Text 19"/>
           <p:cNvSpPr/>
           <p:nvPr/>
         </p:nvSpPr>
@@ -6056,7 +5896,7 @@
       </p:sp>
       <p:sp>
         <p:nvSpPr>
-          <p:cNvPr id="24" name="Shape 22"/>
+          <p:cNvPr id="22" name="Shape 20"/>
           <p:cNvSpPr/>
           <p:nvPr/>
         </p:nvSpPr>
@@ -6076,7 +5916,7 @@
       </p:sp>
       <p:sp>
         <p:nvSpPr>
-          <p:cNvPr id="25" name="Shape 23"/>
+          <p:cNvPr id="23" name="Shape 21"/>
           <p:cNvSpPr/>
           <p:nvPr/>
         </p:nvSpPr>
@@ -6096,7 +5936,7 @@
       </p:sp>
       <p:sp>
         <p:nvSpPr>
-          <p:cNvPr id="26" name="Text 24"/>
+          <p:cNvPr id="24" name="Text 22"/>
           <p:cNvSpPr/>
           <p:nvPr/>
         </p:nvSpPr>
@@ -6135,7 +5975,7 @@
       </p:sp>
       <p:sp>
         <p:nvSpPr>
-          <p:cNvPr id="27" name="Shape 25"/>
+          <p:cNvPr id="25" name="Shape 23"/>
           <p:cNvSpPr/>
           <p:nvPr/>
         </p:nvSpPr>
@@ -6155,7 +5995,7 @@
       </p:sp>
       <p:sp>
         <p:nvSpPr>
-          <p:cNvPr id="28" name="Text 26"/>
+          <p:cNvPr id="26" name="Text 24"/>
           <p:cNvSpPr/>
           <p:nvPr/>
         </p:nvSpPr>
@@ -6194,7 +6034,7 @@
       </p:sp>
       <p:sp>
         <p:nvSpPr>
-          <p:cNvPr id="29" name="Shape 27"/>
+          <p:cNvPr id="27" name="Shape 25"/>
           <p:cNvSpPr/>
           <p:nvPr/>
         </p:nvSpPr>
@@ -6226,7 +6066,7 @@
       </p:sp>
       <p:pic>
         <p:nvPicPr>
-          <p:cNvPr id="30" name="Image 0" descr="/sessions/exciting-charming-faraday/mnt/wc26/WorldCupTrophy.jpeg">    </p:cNvPr>
+          <p:cNvPr id="28" name="Image 0" descr="/sessions/exciting-charming-faraday/mnt/wc26/WorldCupTrophy.jpeg">    </p:cNvPr>
           <p:cNvPicPr>
             <a:picLocks noChangeAspect="1"/>
           </p:cNvPicPr>
@@ -6250,7 +6090,7 @@
       </p:pic>
       <p:sp>
         <p:nvSpPr>
-          <p:cNvPr id="31" name="Text 28"/>
+          <p:cNvPr id="29" name="Text 26"/>
           <p:cNvSpPr/>
           <p:nvPr/>
         </p:nvSpPr>
@@ -6321,47 +6161,7 @@
       </p:grpSpPr>
       <p:sp>
         <p:nvSpPr>
-          <p:cNvPr id="2" name="Shape 0"/>
-          <p:cNvSpPr/>
-          <p:nvPr/>
-        </p:nvSpPr>
-        <p:spPr>
-          <a:xfrm>
-            <a:off x="0" y="0"/>
-            <a:ext cx="9144000" cy="137160"/>
-          </a:xfrm>
-          <a:prstGeom prst="rect">
-            <a:avLst/>
-          </a:prstGeom>
-          <a:solidFill>
-            <a:srgbClr val="FF9E16"/>
-          </a:solidFill>
-          <a:ln/>
-        </p:spPr>
-      </p:sp>
-      <p:sp>
-        <p:nvSpPr>
-          <p:cNvPr id="3" name="Shape 1"/>
-          <p:cNvSpPr/>
-          <p:nvPr/>
-        </p:nvSpPr>
-        <p:spPr>
-          <a:xfrm>
-            <a:off x="0" y="0"/>
-            <a:ext cx="164592" cy="5143500"/>
-          </a:xfrm>
-          <a:prstGeom prst="rect">
-            <a:avLst/>
-          </a:prstGeom>
-          <a:solidFill>
-            <a:srgbClr val="009EDF"/>
-          </a:solidFill>
-          <a:ln/>
-        </p:spPr>
-      </p:sp>
-      <p:sp>
-        <p:nvSpPr>
-          <p:cNvPr id="4" name="Text 2"/>
+          <p:cNvPr id="2" name="Text 0"/>
           <p:cNvSpPr/>
           <p:nvPr/>
         </p:nvSpPr>
@@ -6400,7 +6200,7 @@
       </p:sp>
       <p:sp>
         <p:nvSpPr>
-          <p:cNvPr id="5" name="Shape 3"/>
+          <p:cNvPr id="3" name="Shape 1"/>
           <p:cNvSpPr/>
           <p:nvPr/>
         </p:nvSpPr>
@@ -6420,7 +6220,7 @@
       </p:sp>
       <p:sp>
         <p:nvSpPr>
-          <p:cNvPr id="6" name="Shape 4"/>
+          <p:cNvPr id="4" name="Shape 2"/>
           <p:cNvSpPr/>
           <p:nvPr/>
         </p:nvSpPr>
@@ -6452,7 +6252,7 @@
       </p:sp>
       <p:sp>
         <p:nvSpPr>
-          <p:cNvPr id="7" name="Shape 5"/>
+          <p:cNvPr id="5" name="Shape 3"/>
           <p:cNvSpPr/>
           <p:nvPr/>
         </p:nvSpPr>
@@ -6472,7 +6272,7 @@
       </p:sp>
       <p:sp>
         <p:nvSpPr>
-          <p:cNvPr id="8" name="Text 6"/>
+          <p:cNvPr id="6" name="Text 4"/>
           <p:cNvSpPr/>
           <p:nvPr/>
         </p:nvSpPr>
@@ -6511,7 +6311,7 @@
       </p:sp>
       <p:sp>
         <p:nvSpPr>
-          <p:cNvPr id="9" name="Text 7"/>
+          <p:cNvPr id="7" name="Text 5"/>
           <p:cNvSpPr/>
           <p:nvPr/>
         </p:nvSpPr>
@@ -6550,7 +6350,7 @@
       </p:sp>
       <p:sp>
         <p:nvSpPr>
-          <p:cNvPr id="10" name="Shape 8"/>
+          <p:cNvPr id="8" name="Shape 6"/>
           <p:cNvSpPr/>
           <p:nvPr/>
         </p:nvSpPr>
@@ -6570,7 +6370,7 @@
       </p:sp>
       <p:sp>
         <p:nvSpPr>
-          <p:cNvPr id="11" name="Text 9"/>
+          <p:cNvPr id="9" name="Text 7"/>
           <p:cNvSpPr/>
           <p:nvPr/>
         </p:nvSpPr>
@@ -6612,7 +6412,7 @@
       </p:sp>
       <p:sp>
         <p:nvSpPr>
-          <p:cNvPr id="12" name="Shape 10"/>
+          <p:cNvPr id="10" name="Shape 8"/>
           <p:cNvSpPr/>
           <p:nvPr/>
         </p:nvSpPr>
@@ -6644,7 +6444,7 @@
       </p:sp>
       <p:sp>
         <p:nvSpPr>
-          <p:cNvPr id="13" name="Shape 11"/>
+          <p:cNvPr id="11" name="Shape 9"/>
           <p:cNvSpPr/>
           <p:nvPr/>
         </p:nvSpPr>
@@ -6664,7 +6464,7 @@
       </p:sp>
       <p:sp>
         <p:nvSpPr>
-          <p:cNvPr id="14" name="Text 12"/>
+          <p:cNvPr id="12" name="Text 10"/>
           <p:cNvSpPr/>
           <p:nvPr/>
         </p:nvSpPr>
@@ -6703,7 +6503,7 @@
       </p:sp>
       <p:sp>
         <p:nvSpPr>
-          <p:cNvPr id="15" name="Text 13"/>
+          <p:cNvPr id="13" name="Text 11"/>
           <p:cNvSpPr/>
           <p:nvPr/>
         </p:nvSpPr>
@@ -6742,7 +6542,7 @@
       </p:sp>
       <p:sp>
         <p:nvSpPr>
-          <p:cNvPr id="16" name="Shape 14"/>
+          <p:cNvPr id="14" name="Shape 12"/>
           <p:cNvSpPr/>
           <p:nvPr/>
         </p:nvSpPr>
@@ -6762,7 +6562,7 @@
       </p:sp>
       <p:sp>
         <p:nvSpPr>
-          <p:cNvPr id="17" name="Text 15"/>
+          <p:cNvPr id="15" name="Text 13"/>
           <p:cNvSpPr/>
           <p:nvPr/>
         </p:nvSpPr>
@@ -6804,7 +6604,7 @@
       </p:sp>
       <p:sp>
         <p:nvSpPr>
-          <p:cNvPr id="18" name="Shape 16"/>
+          <p:cNvPr id="16" name="Shape 14"/>
           <p:cNvSpPr/>
           <p:nvPr/>
         </p:nvSpPr>
@@ -6836,7 +6636,7 @@
       </p:sp>
       <p:sp>
         <p:nvSpPr>
-          <p:cNvPr id="19" name="Shape 17"/>
+          <p:cNvPr id="17" name="Shape 15"/>
           <p:cNvSpPr/>
           <p:nvPr/>
         </p:nvSpPr>
@@ -6856,7 +6656,7 @@
       </p:sp>
       <p:sp>
         <p:nvSpPr>
-          <p:cNvPr id="20" name="Text 18"/>
+          <p:cNvPr id="18" name="Text 16"/>
           <p:cNvSpPr/>
           <p:nvPr/>
         </p:nvSpPr>
@@ -6895,7 +6695,7 @@
       </p:sp>
       <p:sp>
         <p:nvSpPr>
-          <p:cNvPr id="21" name="Text 19"/>
+          <p:cNvPr id="19" name="Text 17"/>
           <p:cNvSpPr/>
           <p:nvPr/>
         </p:nvSpPr>
@@ -6934,7 +6734,7 @@
       </p:sp>
       <p:sp>
         <p:nvSpPr>
-          <p:cNvPr id="22" name="Shape 20"/>
+          <p:cNvPr id="20" name="Shape 18"/>
           <p:cNvSpPr/>
           <p:nvPr/>
         </p:nvSpPr>
@@ -6954,7 +6754,7 @@
       </p:sp>
       <p:sp>
         <p:nvSpPr>
-          <p:cNvPr id="23" name="Text 21"/>
+          <p:cNvPr id="21" name="Text 19"/>
           <p:cNvSpPr/>
           <p:nvPr/>
         </p:nvSpPr>
@@ -7028,47 +6828,7 @@
       </p:grpSpPr>
       <p:sp>
         <p:nvSpPr>
-          <p:cNvPr id="2" name="Shape 0"/>
-          <p:cNvSpPr/>
-          <p:nvPr/>
-        </p:nvSpPr>
-        <p:spPr>
-          <a:xfrm>
-            <a:off x="0" y="0"/>
-            <a:ext cx="9144000" cy="137160"/>
-          </a:xfrm>
-          <a:prstGeom prst="rect">
-            <a:avLst/>
-          </a:prstGeom>
-          <a:solidFill>
-            <a:srgbClr val="FF9E16"/>
-          </a:solidFill>
-          <a:ln/>
-        </p:spPr>
-      </p:sp>
-      <p:sp>
-        <p:nvSpPr>
-          <p:cNvPr id="3" name="Shape 1"/>
-          <p:cNvSpPr/>
-          <p:nvPr/>
-        </p:nvSpPr>
-        <p:spPr>
-          <a:xfrm>
-            <a:off x="0" y="0"/>
-            <a:ext cx="164592" cy="5143500"/>
-          </a:xfrm>
-          <a:prstGeom prst="rect">
-            <a:avLst/>
-          </a:prstGeom>
-          <a:solidFill>
-            <a:srgbClr val="009EDF"/>
-          </a:solidFill>
-          <a:ln/>
-        </p:spPr>
-      </p:sp>
-      <p:sp>
-        <p:nvSpPr>
-          <p:cNvPr id="4" name="Text 2"/>
+          <p:cNvPr id="2" name="Text 0"/>
           <p:cNvSpPr/>
           <p:nvPr/>
         </p:nvSpPr>
@@ -7107,7 +6867,7 @@
       </p:sp>
       <p:sp>
         <p:nvSpPr>
-          <p:cNvPr id="5" name="Shape 3"/>
+          <p:cNvPr id="3" name="Shape 1"/>
           <p:cNvSpPr/>
           <p:nvPr/>
         </p:nvSpPr>
@@ -7127,7 +6887,7 @@
       </p:sp>
       <p:sp>
         <p:nvSpPr>
-          <p:cNvPr id="6" name="Shape 4"/>
+          <p:cNvPr id="4" name="Shape 2"/>
           <p:cNvSpPr/>
           <p:nvPr/>
         </p:nvSpPr>
@@ -7159,7 +6919,7 @@
       </p:sp>
       <p:sp>
         <p:nvSpPr>
-          <p:cNvPr id="7" name="Shape 5"/>
+          <p:cNvPr id="5" name="Shape 3"/>
           <p:cNvSpPr/>
           <p:nvPr/>
         </p:nvSpPr>
@@ -7179,7 +6939,7 @@
       </p:sp>
       <p:sp>
         <p:nvSpPr>
-          <p:cNvPr id="8" name="Text 6"/>
+          <p:cNvPr id="6" name="Text 4"/>
           <p:cNvSpPr/>
           <p:nvPr/>
         </p:nvSpPr>
@@ -7218,7 +6978,7 @@
       </p:sp>
       <p:sp>
         <p:nvSpPr>
-          <p:cNvPr id="9" name="Shape 7"/>
+          <p:cNvPr id="7" name="Shape 5"/>
           <p:cNvSpPr/>
           <p:nvPr/>
         </p:nvSpPr>
@@ -7240,7 +7000,7 @@
       </p:sp>
       <p:sp>
         <p:nvSpPr>
-          <p:cNvPr id="10" name="Text 8"/>
+          <p:cNvPr id="8" name="Text 6"/>
           <p:cNvSpPr/>
           <p:nvPr/>
         </p:nvSpPr>
@@ -7279,7 +7039,7 @@
       </p:sp>
       <p:sp>
         <p:nvSpPr>
-          <p:cNvPr id="11" name="Text 9"/>
+          <p:cNvPr id="9" name="Text 7"/>
           <p:cNvSpPr/>
           <p:nvPr/>
         </p:nvSpPr>
@@ -7318,7 +7078,7 @@
       </p:sp>
       <p:sp>
         <p:nvSpPr>
-          <p:cNvPr id="12" name="Shape 10"/>
+          <p:cNvPr id="10" name="Shape 8"/>
           <p:cNvSpPr/>
           <p:nvPr/>
         </p:nvSpPr>
@@ -7338,7 +7098,7 @@
       </p:sp>
       <p:sp>
         <p:nvSpPr>
-          <p:cNvPr id="13" name="Text 11"/>
+          <p:cNvPr id="11" name="Text 9"/>
           <p:cNvSpPr/>
           <p:nvPr/>
         </p:nvSpPr>
@@ -7409,7 +7169,7 @@
       </p:sp>
       <p:sp>
         <p:nvSpPr>
-          <p:cNvPr id="14" name="Text 12">
+          <p:cNvPr id="12" name="Text 10">
             <a:hlinkClick r:id="rId1" tooltip="Watch on YouTube"/>
           </p:cNvPr>
           <p:cNvSpPr/>
@@ -7457,7 +7217,7 @@
       </p:sp>
       <p:sp>
         <p:nvSpPr>
-          <p:cNvPr id="15" name="Shape 13"/>
+          <p:cNvPr id="13" name="Shape 11"/>
           <p:cNvSpPr/>
           <p:nvPr/>
         </p:nvSpPr>
@@ -7489,7 +7249,7 @@
       </p:sp>
       <p:sp>
         <p:nvSpPr>
-          <p:cNvPr id="16" name="Shape 14"/>
+          <p:cNvPr id="14" name="Shape 12"/>
           <p:cNvSpPr/>
           <p:nvPr/>
         </p:nvSpPr>
@@ -7509,7 +7269,7 @@
       </p:sp>
       <p:sp>
         <p:nvSpPr>
-          <p:cNvPr id="17" name="Text 15"/>
+          <p:cNvPr id="15" name="Text 13"/>
           <p:cNvSpPr/>
           <p:nvPr/>
         </p:nvSpPr>
@@ -7548,7 +7308,7 @@
       </p:sp>
       <p:sp>
         <p:nvSpPr>
-          <p:cNvPr id="18" name="Shape 16"/>
+          <p:cNvPr id="16" name="Shape 14"/>
           <p:cNvSpPr/>
           <p:nvPr/>
         </p:nvSpPr>
@@ -7570,7 +7330,7 @@
       </p:sp>
       <p:sp>
         <p:nvSpPr>
-          <p:cNvPr id="19" name="Text 17"/>
+          <p:cNvPr id="17" name="Text 15"/>
           <p:cNvSpPr/>
           <p:nvPr/>
         </p:nvSpPr>
@@ -7609,7 +7369,7 @@
       </p:sp>
       <p:sp>
         <p:nvSpPr>
-          <p:cNvPr id="20" name="Text 18"/>
+          <p:cNvPr id="18" name="Text 16"/>
           <p:cNvSpPr/>
           <p:nvPr/>
         </p:nvSpPr>
@@ -7648,7 +7408,7 @@
       </p:sp>
       <p:sp>
         <p:nvSpPr>
-          <p:cNvPr id="21" name="Shape 19"/>
+          <p:cNvPr id="19" name="Shape 17"/>
           <p:cNvSpPr/>
           <p:nvPr/>
         </p:nvSpPr>
@@ -7668,7 +7428,7 @@
       </p:sp>
       <p:sp>
         <p:nvSpPr>
-          <p:cNvPr id="22" name="Text 20"/>
+          <p:cNvPr id="20" name="Text 18"/>
           <p:cNvSpPr/>
           <p:nvPr/>
         </p:nvSpPr>
@@ -7739,7 +7499,7 @@
       </p:sp>
       <p:sp>
         <p:nvSpPr>
-          <p:cNvPr id="23" name="Text 21">
+          <p:cNvPr id="21" name="Text 19">
             <a:hlinkClick r:id="rId2" tooltip="Watch on YouTube"/>
           </p:cNvPr>
           <p:cNvSpPr/>
@@ -7787,7 +7547,7 @@
       </p:sp>
       <p:sp>
         <p:nvSpPr>
-          <p:cNvPr id="24" name="Shape 22"/>
+          <p:cNvPr id="22" name="Shape 20"/>
           <p:cNvSpPr/>
           <p:nvPr/>
         </p:nvSpPr>
@@ -7819,7 +7579,7 @@
       </p:sp>
       <p:sp>
         <p:nvSpPr>
-          <p:cNvPr id="25" name="Shape 23"/>
+          <p:cNvPr id="23" name="Shape 21"/>
           <p:cNvSpPr/>
           <p:nvPr/>
         </p:nvSpPr>
@@ -7839,7 +7599,7 @@
       </p:sp>
       <p:sp>
         <p:nvSpPr>
-          <p:cNvPr id="26" name="Text 24"/>
+          <p:cNvPr id="24" name="Text 22"/>
           <p:cNvSpPr/>
           <p:nvPr/>
         </p:nvSpPr>
@@ -7878,7 +7638,7 @@
       </p:sp>
       <p:sp>
         <p:nvSpPr>
-          <p:cNvPr id="27" name="Shape 25"/>
+          <p:cNvPr id="25" name="Shape 23"/>
           <p:cNvSpPr/>
           <p:nvPr/>
         </p:nvSpPr>
@@ -7900,7 +7660,7 @@
       </p:sp>
       <p:sp>
         <p:nvSpPr>
-          <p:cNvPr id="28" name="Text 26"/>
+          <p:cNvPr id="26" name="Text 24"/>
           <p:cNvSpPr/>
           <p:nvPr/>
         </p:nvSpPr>
@@ -7939,7 +7699,7 @@
       </p:sp>
       <p:sp>
         <p:nvSpPr>
-          <p:cNvPr id="29" name="Text 27"/>
+          <p:cNvPr id="27" name="Text 25"/>
           <p:cNvSpPr/>
           <p:nvPr/>
         </p:nvSpPr>
@@ -7978,7 +7738,7 @@
       </p:sp>
       <p:sp>
         <p:nvSpPr>
-          <p:cNvPr id="30" name="Shape 28"/>
+          <p:cNvPr id="28" name="Shape 26"/>
           <p:cNvSpPr/>
           <p:nvPr/>
         </p:nvSpPr>
@@ -7998,7 +7758,7 @@
       </p:sp>
       <p:sp>
         <p:nvSpPr>
-          <p:cNvPr id="31" name="Text 29"/>
+          <p:cNvPr id="29" name="Text 27"/>
           <p:cNvSpPr/>
           <p:nvPr/>
         </p:nvSpPr>
@@ -8069,7 +7829,7 @@
       </p:sp>
       <p:sp>
         <p:nvSpPr>
-          <p:cNvPr id="32" name="Text 30">
+          <p:cNvPr id="30" name="Text 28">
             <a:hlinkClick r:id="rId3" tooltip="Watch on YouTube"/>
           </p:cNvPr>
           <p:cNvSpPr/>
@@ -8149,47 +7909,7 @@
       </p:grpSpPr>
       <p:sp>
         <p:nvSpPr>
-          <p:cNvPr id="2" name="Shape 0"/>
-          <p:cNvSpPr/>
-          <p:nvPr/>
-        </p:nvSpPr>
-        <p:spPr>
-          <a:xfrm>
-            <a:off x="0" y="0"/>
-            <a:ext cx="9144000" cy="137160"/>
-          </a:xfrm>
-          <a:prstGeom prst="rect">
-            <a:avLst/>
-          </a:prstGeom>
-          <a:solidFill>
-            <a:srgbClr val="FF9E16"/>
-          </a:solidFill>
-          <a:ln/>
-        </p:spPr>
-      </p:sp>
-      <p:sp>
-        <p:nvSpPr>
-          <p:cNvPr id="3" name="Shape 1"/>
-          <p:cNvSpPr/>
-          <p:nvPr/>
-        </p:nvSpPr>
-        <p:spPr>
-          <a:xfrm>
-            <a:off x="0" y="0"/>
-            <a:ext cx="164592" cy="5143500"/>
-          </a:xfrm>
-          <a:prstGeom prst="rect">
-            <a:avLst/>
-          </a:prstGeom>
-          <a:solidFill>
-            <a:srgbClr val="009EDF"/>
-          </a:solidFill>
-          <a:ln/>
-        </p:spPr>
-      </p:sp>
-      <p:sp>
-        <p:nvSpPr>
-          <p:cNvPr id="4" name="Text 2"/>
+          <p:cNvPr id="2" name="Text 0"/>
           <p:cNvSpPr/>
           <p:nvPr/>
         </p:nvSpPr>
@@ -8228,7 +7948,7 @@
       </p:sp>
       <p:sp>
         <p:nvSpPr>
-          <p:cNvPr id="5" name="Shape 3"/>
+          <p:cNvPr id="3" name="Shape 1"/>
           <p:cNvSpPr/>
           <p:nvPr/>
         </p:nvSpPr>
@@ -8248,7 +7968,7 @@
       </p:sp>
       <p:sp>
         <p:nvSpPr>
-          <p:cNvPr id="6" name="Shape 4"/>
+          <p:cNvPr id="4" name="Shape 2"/>
           <p:cNvSpPr/>
           <p:nvPr/>
         </p:nvSpPr>
@@ -8280,7 +8000,7 @@
       </p:sp>
       <p:sp>
         <p:nvSpPr>
-          <p:cNvPr id="7" name="Shape 5"/>
+          <p:cNvPr id="5" name="Shape 3"/>
           <p:cNvSpPr/>
           <p:nvPr/>
         </p:nvSpPr>
@@ -8300,7 +8020,7 @@
       </p:sp>
       <p:sp>
         <p:nvSpPr>
-          <p:cNvPr id="8" name="Text 6"/>
+          <p:cNvPr id="6" name="Text 4"/>
           <p:cNvSpPr/>
           <p:nvPr/>
         </p:nvSpPr>
@@ -8339,7 +8059,7 @@
       </p:sp>
       <p:sp>
         <p:nvSpPr>
-          <p:cNvPr id="9" name="Shape 7"/>
+          <p:cNvPr id="7" name="Shape 5"/>
           <p:cNvSpPr/>
           <p:nvPr/>
         </p:nvSpPr>
@@ -8359,7 +8079,7 @@
       </p:sp>
       <p:sp>
         <p:nvSpPr>
-          <p:cNvPr id="10" name="Text 8"/>
+          <p:cNvPr id="8" name="Text 6"/>
           <p:cNvSpPr/>
           <p:nvPr/>
         </p:nvSpPr>
@@ -8415,7 +8135,7 @@
       </p:sp>
       <p:sp>
         <p:nvSpPr>
-          <p:cNvPr id="11" name="Shape 9"/>
+          <p:cNvPr id="9" name="Shape 7"/>
           <p:cNvSpPr/>
           <p:nvPr/>
         </p:nvSpPr>
@@ -8447,7 +8167,7 @@
       </p:sp>
       <p:sp>
         <p:nvSpPr>
-          <p:cNvPr id="12" name="Shape 10"/>
+          <p:cNvPr id="10" name="Shape 8"/>
           <p:cNvSpPr/>
           <p:nvPr/>
         </p:nvSpPr>
@@ -8467,7 +8187,7 @@
       </p:sp>
       <p:sp>
         <p:nvSpPr>
-          <p:cNvPr id="13" name="Text 11"/>
+          <p:cNvPr id="11" name="Text 9"/>
           <p:cNvSpPr/>
           <p:nvPr/>
         </p:nvSpPr>
@@ -8506,7 +8226,7 @@
       </p:sp>
       <p:sp>
         <p:nvSpPr>
-          <p:cNvPr id="14" name="Shape 12"/>
+          <p:cNvPr id="12" name="Shape 10"/>
           <p:cNvSpPr/>
           <p:nvPr/>
         </p:nvSpPr>
@@ -8526,7 +8246,7 @@
       </p:sp>
       <p:sp>
         <p:nvSpPr>
-          <p:cNvPr id="15" name="Text 13"/>
+          <p:cNvPr id="13" name="Text 11"/>
           <p:cNvSpPr/>
           <p:nvPr/>
         </p:nvSpPr>
@@ -8582,7 +8302,7 @@
       </p:sp>
       <p:sp>
         <p:nvSpPr>
-          <p:cNvPr id="16" name="Shape 14"/>
+          <p:cNvPr id="14" name="Shape 12"/>
           <p:cNvSpPr/>
           <p:nvPr/>
         </p:nvSpPr>
@@ -8614,7 +8334,7 @@
       </p:sp>
       <p:sp>
         <p:nvSpPr>
-          <p:cNvPr id="17" name="Shape 15"/>
+          <p:cNvPr id="15" name="Shape 13"/>
           <p:cNvSpPr/>
           <p:nvPr/>
         </p:nvSpPr>
@@ -8634,7 +8354,7 @@
       </p:sp>
       <p:sp>
         <p:nvSpPr>
-          <p:cNvPr id="18" name="Text 16"/>
+          <p:cNvPr id="16" name="Text 14"/>
           <p:cNvSpPr/>
           <p:nvPr/>
         </p:nvSpPr>
@@ -8673,7 +8393,7 @@
       </p:sp>
       <p:sp>
         <p:nvSpPr>
-          <p:cNvPr id="19" name="Shape 17"/>
+          <p:cNvPr id="17" name="Shape 15"/>
           <p:cNvSpPr/>
           <p:nvPr/>
         </p:nvSpPr>
@@ -8693,7 +8413,7 @@
       </p:sp>
       <p:sp>
         <p:nvSpPr>
-          <p:cNvPr id="20" name="Text 18"/>
+          <p:cNvPr id="18" name="Text 16"/>
           <p:cNvSpPr/>
           <p:nvPr/>
         </p:nvSpPr>
@@ -8749,7 +8469,7 @@
       </p:sp>
       <p:sp>
         <p:nvSpPr>
-          <p:cNvPr id="21" name="Shape 19"/>
+          <p:cNvPr id="19" name="Shape 17"/>
           <p:cNvSpPr/>
           <p:nvPr/>
         </p:nvSpPr>
@@ -8781,7 +8501,7 @@
       </p:sp>
       <p:sp>
         <p:nvSpPr>
-          <p:cNvPr id="22" name="Shape 20"/>
+          <p:cNvPr id="20" name="Shape 18"/>
           <p:cNvSpPr/>
           <p:nvPr/>
         </p:nvSpPr>
@@ -8801,7 +8521,7 @@
       </p:sp>
       <p:sp>
         <p:nvSpPr>
-          <p:cNvPr id="23" name="Text 21"/>
+          <p:cNvPr id="21" name="Text 19"/>
           <p:cNvSpPr/>
           <p:nvPr/>
         </p:nvSpPr>
@@ -8840,7 +8560,7 @@
       </p:sp>
       <p:sp>
         <p:nvSpPr>
-          <p:cNvPr id="24" name="Shape 22"/>
+          <p:cNvPr id="22" name="Shape 20"/>
           <p:cNvSpPr/>
           <p:nvPr/>
         </p:nvSpPr>
@@ -8860,7 +8580,7 @@
       </p:sp>
       <p:sp>
         <p:nvSpPr>
-          <p:cNvPr id="25" name="Text 23"/>
+          <p:cNvPr id="23" name="Text 21"/>
           <p:cNvSpPr/>
           <p:nvPr/>
         </p:nvSpPr>
@@ -8916,7 +8636,7 @@
       </p:sp>
       <p:sp>
         <p:nvSpPr>
-          <p:cNvPr id="26" name="Text 24"/>
+          <p:cNvPr id="24" name="Text 22"/>
           <p:cNvSpPr/>
           <p:nvPr/>
         </p:nvSpPr>
@@ -8987,47 +8707,7 @@
       </p:grpSpPr>
       <p:sp>
         <p:nvSpPr>
-          <p:cNvPr id="2" name="Shape 0"/>
-          <p:cNvSpPr/>
-          <p:nvPr/>
-        </p:nvSpPr>
-        <p:spPr>
-          <a:xfrm>
-            <a:off x="0" y="0"/>
-            <a:ext cx="9144000" cy="137160"/>
-          </a:xfrm>
-          <a:prstGeom prst="rect">
-            <a:avLst/>
-          </a:prstGeom>
-          <a:solidFill>
-            <a:srgbClr val="FF9E16"/>
-          </a:solidFill>
-          <a:ln/>
-        </p:spPr>
-      </p:sp>
-      <p:sp>
-        <p:nvSpPr>
-          <p:cNvPr id="3" name="Shape 1"/>
-          <p:cNvSpPr/>
-          <p:nvPr/>
-        </p:nvSpPr>
-        <p:spPr>
-          <a:xfrm>
-            <a:off x="0" y="0"/>
-            <a:ext cx="164592" cy="5143500"/>
-          </a:xfrm>
-          <a:prstGeom prst="rect">
-            <a:avLst/>
-          </a:prstGeom>
-          <a:solidFill>
-            <a:srgbClr val="009EDF"/>
-          </a:solidFill>
-          <a:ln/>
-        </p:spPr>
-      </p:sp>
-      <p:sp>
-        <p:nvSpPr>
-          <p:cNvPr id="4" name="Text 2"/>
+          <p:cNvPr id="2" name="Text 0"/>
           <p:cNvSpPr/>
           <p:nvPr/>
         </p:nvSpPr>
@@ -9066,7 +8746,7 @@
       </p:sp>
       <p:sp>
         <p:nvSpPr>
-          <p:cNvPr id="5" name="Shape 3"/>
+          <p:cNvPr id="3" name="Shape 1"/>
           <p:cNvSpPr/>
           <p:nvPr/>
         </p:nvSpPr>
@@ -9086,7 +8766,7 @@
       </p:sp>
       <p:sp>
         <p:nvSpPr>
-          <p:cNvPr id="6" name="Shape 4"/>
+          <p:cNvPr id="4" name="Shape 2"/>
           <p:cNvSpPr/>
           <p:nvPr/>
         </p:nvSpPr>
@@ -9118,7 +8798,7 @@
       </p:sp>
       <p:pic>
         <p:nvPicPr>
-          <p:cNvPr id="7" name="Image 0" descr="/sessions/exciting-charming-faraday/mnt/outputs/wc2026_map.png">    </p:cNvPr>
+          <p:cNvPr id="5" name="Image 0" descr="/sessions/exciting-charming-faraday/mnt/outputs/wc2026_map.png">    </p:cNvPr>
           <p:cNvPicPr>
             <a:picLocks noChangeAspect="1"/>
           </p:cNvPicPr>
@@ -9174,47 +8854,7 @@
       </p:grpSpPr>
       <p:sp>
         <p:nvSpPr>
-          <p:cNvPr id="2" name="Shape 0"/>
-          <p:cNvSpPr/>
-          <p:nvPr/>
-        </p:nvSpPr>
-        <p:spPr>
-          <a:xfrm>
-            <a:off x="0" y="0"/>
-            <a:ext cx="9144000" cy="137160"/>
-          </a:xfrm>
-          <a:prstGeom prst="rect">
-            <a:avLst/>
-          </a:prstGeom>
-          <a:solidFill>
-            <a:srgbClr val="FF9E16"/>
-          </a:solidFill>
-          <a:ln/>
-        </p:spPr>
-      </p:sp>
-      <p:sp>
-        <p:nvSpPr>
-          <p:cNvPr id="3" name="Shape 1"/>
-          <p:cNvSpPr/>
-          <p:nvPr/>
-        </p:nvSpPr>
-        <p:spPr>
-          <a:xfrm>
-            <a:off x="0" y="0"/>
-            <a:ext cx="164592" cy="5143500"/>
-          </a:xfrm>
-          <a:prstGeom prst="rect">
-            <a:avLst/>
-          </a:prstGeom>
-          <a:solidFill>
-            <a:srgbClr val="009EDF"/>
-          </a:solidFill>
-          <a:ln/>
-        </p:spPr>
-      </p:sp>
-      <p:sp>
-        <p:nvSpPr>
-          <p:cNvPr id="4" name="Text 2"/>
+          <p:cNvPr id="2" name="Text 0"/>
           <p:cNvSpPr/>
           <p:nvPr/>
         </p:nvSpPr>
@@ -9253,7 +8893,7 @@
       </p:sp>
       <p:sp>
         <p:nvSpPr>
-          <p:cNvPr id="5" name="Shape 3"/>
+          <p:cNvPr id="3" name="Shape 1"/>
           <p:cNvSpPr/>
           <p:nvPr/>
         </p:nvSpPr>
@@ -9273,7 +8913,7 @@
       </p:sp>
       <p:sp>
         <p:nvSpPr>
-          <p:cNvPr id="6" name="Text 4"/>
+          <p:cNvPr id="4" name="Text 2"/>
           <p:cNvSpPr/>
           <p:nvPr/>
         </p:nvSpPr>
@@ -9312,7 +8952,7 @@
       </p:sp>
       <p:sp>
         <p:nvSpPr>
-          <p:cNvPr id="7" name="Shape 5"/>
+          <p:cNvPr id="5" name="Shape 3"/>
           <p:cNvSpPr/>
           <p:nvPr/>
         </p:nvSpPr>
@@ -9344,7 +8984,7 @@
       </p:sp>
       <p:sp>
         <p:nvSpPr>
-          <p:cNvPr id="8" name="Shape 6"/>
+          <p:cNvPr id="6" name="Shape 4"/>
           <p:cNvSpPr/>
           <p:nvPr/>
         </p:nvSpPr>
@@ -9364,7 +9004,7 @@
       </p:sp>
       <p:sp>
         <p:nvSpPr>
-          <p:cNvPr id="9" name="Text 7"/>
+          <p:cNvPr id="7" name="Text 5"/>
           <p:cNvSpPr/>
           <p:nvPr/>
         </p:nvSpPr>
@@ -9403,7 +9043,7 @@
       </p:sp>
       <p:sp>
         <p:nvSpPr>
-          <p:cNvPr id="10" name="Text 8"/>
+          <p:cNvPr id="8" name="Text 6"/>
           <p:cNvSpPr/>
           <p:nvPr/>
         </p:nvSpPr>
@@ -9442,7 +9082,7 @@
       </p:sp>
       <p:sp>
         <p:nvSpPr>
-          <p:cNvPr id="11" name="Shape 9"/>
+          <p:cNvPr id="9" name="Shape 7"/>
           <p:cNvSpPr/>
           <p:nvPr/>
         </p:nvSpPr>
@@ -9462,7 +9102,7 @@
       </p:sp>
       <p:sp>
         <p:nvSpPr>
-          <p:cNvPr id="12" name="Text 10"/>
+          <p:cNvPr id="10" name="Text 8"/>
           <p:cNvSpPr/>
           <p:nvPr/>
         </p:nvSpPr>
@@ -9501,7 +9141,7 @@
       </p:sp>
       <p:sp>
         <p:nvSpPr>
-          <p:cNvPr id="13" name="Shape 11"/>
+          <p:cNvPr id="11" name="Shape 9"/>
           <p:cNvSpPr/>
           <p:nvPr/>
         </p:nvSpPr>
@@ -9521,7 +9161,7 @@
       </p:sp>
       <p:sp>
         <p:nvSpPr>
-          <p:cNvPr id="14" name="Text 12"/>
+          <p:cNvPr id="12" name="Text 10"/>
           <p:cNvSpPr/>
           <p:nvPr/>
         </p:nvSpPr>
@@ -9560,7 +9200,7 @@
       </p:sp>
       <p:sp>
         <p:nvSpPr>
-          <p:cNvPr id="15" name="Shape 13"/>
+          <p:cNvPr id="13" name="Shape 11"/>
           <p:cNvSpPr/>
           <p:nvPr/>
         </p:nvSpPr>
@@ -9580,7 +9220,7 @@
       </p:sp>
       <p:sp>
         <p:nvSpPr>
-          <p:cNvPr id="16" name="Text 14"/>
+          <p:cNvPr id="14" name="Text 12"/>
           <p:cNvSpPr/>
           <p:nvPr/>
         </p:nvSpPr>
@@ -9619,7 +9259,7 @@
       </p:sp>
       <p:sp>
         <p:nvSpPr>
-          <p:cNvPr id="17" name="Shape 15"/>
+          <p:cNvPr id="15" name="Shape 13"/>
           <p:cNvSpPr/>
           <p:nvPr/>
         </p:nvSpPr>
@@ -9639,7 +9279,7 @@
       </p:sp>
       <p:sp>
         <p:nvSpPr>
-          <p:cNvPr id="18" name="Text 16"/>
+          <p:cNvPr id="16" name="Text 14"/>
           <p:cNvSpPr/>
           <p:nvPr/>
         </p:nvSpPr>
@@ -9678,7 +9318,7 @@
       </p:sp>
       <p:sp>
         <p:nvSpPr>
-          <p:cNvPr id="19" name="Shape 17"/>
+          <p:cNvPr id="17" name="Shape 15"/>
           <p:cNvSpPr/>
           <p:nvPr/>
         </p:nvSpPr>
@@ -9698,7 +9338,7 @@
       </p:sp>
       <p:sp>
         <p:nvSpPr>
-          <p:cNvPr id="20" name="Text 18"/>
+          <p:cNvPr id="18" name="Text 16"/>
           <p:cNvSpPr/>
           <p:nvPr/>
         </p:nvSpPr>
@@ -9737,7 +9377,7 @@
       </p:sp>
       <p:sp>
         <p:nvSpPr>
-          <p:cNvPr id="21" name="Shape 19"/>
+          <p:cNvPr id="19" name="Shape 17"/>
           <p:cNvSpPr/>
           <p:nvPr/>
         </p:nvSpPr>
@@ -9757,7 +9397,7 @@
       </p:sp>
       <p:sp>
         <p:nvSpPr>
-          <p:cNvPr id="22" name="Text 20"/>
+          <p:cNvPr id="20" name="Text 18"/>
           <p:cNvSpPr/>
           <p:nvPr/>
         </p:nvSpPr>
@@ -9796,7 +9436,7 @@
       </p:sp>
       <p:sp>
         <p:nvSpPr>
-          <p:cNvPr id="23" name="Shape 21"/>
+          <p:cNvPr id="21" name="Shape 19"/>
           <p:cNvSpPr/>
           <p:nvPr/>
         </p:nvSpPr>
@@ -9816,7 +9456,7 @@
       </p:sp>
       <p:sp>
         <p:nvSpPr>
-          <p:cNvPr id="24" name="Text 22"/>
+          <p:cNvPr id="22" name="Text 20"/>
           <p:cNvSpPr/>
           <p:nvPr/>
         </p:nvSpPr>
@@ -9855,7 +9495,7 @@
       </p:sp>
       <p:sp>
         <p:nvSpPr>
-          <p:cNvPr id="25" name="Shape 23"/>
+          <p:cNvPr id="23" name="Shape 21"/>
           <p:cNvSpPr/>
           <p:nvPr/>
         </p:nvSpPr>
@@ -9875,7 +9515,7 @@
       </p:sp>
       <p:sp>
         <p:nvSpPr>
-          <p:cNvPr id="26" name="Text 24"/>
+          <p:cNvPr id="24" name="Text 22"/>
           <p:cNvSpPr/>
           <p:nvPr/>
         </p:nvSpPr>
@@ -9914,7 +9554,7 @@
       </p:sp>
       <p:sp>
         <p:nvSpPr>
-          <p:cNvPr id="27" name="Shape 25"/>
+          <p:cNvPr id="25" name="Shape 23"/>
           <p:cNvSpPr/>
           <p:nvPr/>
         </p:nvSpPr>
@@ -9934,7 +9574,7 @@
       </p:sp>
       <p:sp>
         <p:nvSpPr>
-          <p:cNvPr id="28" name="Text 26"/>
+          <p:cNvPr id="26" name="Text 24"/>
           <p:cNvSpPr/>
           <p:nvPr/>
         </p:nvSpPr>
@@ -9973,7 +9613,7 @@
       </p:sp>
       <p:sp>
         <p:nvSpPr>
-          <p:cNvPr id="29" name="Shape 27"/>
+          <p:cNvPr id="27" name="Shape 25"/>
           <p:cNvSpPr/>
           <p:nvPr/>
         </p:nvSpPr>
@@ -10005,7 +9645,7 @@
       </p:sp>
       <p:sp>
         <p:nvSpPr>
-          <p:cNvPr id="30" name="Shape 28"/>
+          <p:cNvPr id="28" name="Shape 26"/>
           <p:cNvSpPr/>
           <p:nvPr/>
         </p:nvSpPr>
@@ -10025,7 +9665,7 @@
       </p:sp>
       <p:sp>
         <p:nvSpPr>
-          <p:cNvPr id="31" name="Text 29"/>
+          <p:cNvPr id="29" name="Text 27"/>
           <p:cNvSpPr/>
           <p:nvPr/>
         </p:nvSpPr>
@@ -10064,7 +9704,7 @@
       </p:sp>
       <p:sp>
         <p:nvSpPr>
-          <p:cNvPr id="32" name="Text 30"/>
+          <p:cNvPr id="30" name="Text 28"/>
           <p:cNvSpPr/>
           <p:nvPr/>
         </p:nvSpPr>
@@ -10103,7 +9743,7 @@
       </p:sp>
       <p:sp>
         <p:nvSpPr>
-          <p:cNvPr id="33" name="Shape 31"/>
+          <p:cNvPr id="31" name="Shape 29"/>
           <p:cNvSpPr/>
           <p:nvPr/>
         </p:nvSpPr>
@@ -10123,7 +9763,7 @@
       </p:sp>
       <p:sp>
         <p:nvSpPr>
-          <p:cNvPr id="34" name="Text 32"/>
+          <p:cNvPr id="32" name="Text 30"/>
           <p:cNvSpPr/>
           <p:nvPr/>
         </p:nvSpPr>
@@ -10162,7 +9802,7 @@
       </p:sp>
       <p:sp>
         <p:nvSpPr>
-          <p:cNvPr id="35" name="Text 33"/>
+          <p:cNvPr id="33" name="Text 31"/>
           <p:cNvSpPr/>
           <p:nvPr/>
         </p:nvSpPr>
@@ -10201,7 +9841,7 @@
       </p:sp>
       <p:sp>
         <p:nvSpPr>
-          <p:cNvPr id="36" name="Text 34"/>
+          <p:cNvPr id="34" name="Text 32"/>
           <p:cNvSpPr/>
           <p:nvPr/>
         </p:nvSpPr>
@@ -10240,7 +9880,7 @@
       </p:sp>
       <p:sp>
         <p:nvSpPr>
-          <p:cNvPr id="37" name="Text 35"/>
+          <p:cNvPr id="35" name="Text 33"/>
           <p:cNvSpPr/>
           <p:nvPr/>
         </p:nvSpPr>
@@ -10279,7 +9919,7 @@
       </p:sp>
       <p:sp>
         <p:nvSpPr>
-          <p:cNvPr id="38" name="Text 36"/>
+          <p:cNvPr id="36" name="Text 34"/>
           <p:cNvSpPr/>
           <p:nvPr/>
         </p:nvSpPr>
@@ -10318,7 +9958,7 @@
       </p:sp>
       <p:sp>
         <p:nvSpPr>
-          <p:cNvPr id="39" name="Shape 37"/>
+          <p:cNvPr id="37" name="Shape 35"/>
           <p:cNvSpPr/>
           <p:nvPr/>
         </p:nvSpPr>
@@ -10343,7 +9983,7 @@
       </p:sp>
       <p:sp>
         <p:nvSpPr>
-          <p:cNvPr id="40" name="Shape 38"/>
+          <p:cNvPr id="38" name="Shape 36"/>
           <p:cNvSpPr/>
           <p:nvPr/>
         </p:nvSpPr>
@@ -10363,7 +10003,7 @@
       </p:sp>
       <p:sp>
         <p:nvSpPr>
-          <p:cNvPr id="41" name="Text 39"/>
+          <p:cNvPr id="39" name="Text 37"/>
           <p:cNvSpPr/>
           <p:nvPr/>
         </p:nvSpPr>
@@ -10402,7 +10042,7 @@
       </p:sp>
       <p:sp>
         <p:nvSpPr>
-          <p:cNvPr id="42" name="Text 40"/>
+          <p:cNvPr id="40" name="Text 38"/>
           <p:cNvSpPr/>
           <p:nvPr/>
         </p:nvSpPr>
@@ -10441,7 +10081,7 @@
       </p:sp>
       <p:sp>
         <p:nvSpPr>
-          <p:cNvPr id="43" name="Text 41"/>
+          <p:cNvPr id="41" name="Text 39"/>
           <p:cNvSpPr/>
           <p:nvPr/>
         </p:nvSpPr>
@@ -10480,7 +10120,7 @@
       </p:sp>
       <p:sp>
         <p:nvSpPr>
-          <p:cNvPr id="44" name="Text 42"/>
+          <p:cNvPr id="42" name="Text 40"/>
           <p:cNvSpPr/>
           <p:nvPr/>
         </p:nvSpPr>
@@ -10519,7 +10159,7 @@
       </p:sp>
       <p:sp>
         <p:nvSpPr>
-          <p:cNvPr id="45" name="Text 43"/>
+          <p:cNvPr id="43" name="Text 41"/>
           <p:cNvSpPr/>
           <p:nvPr/>
         </p:nvSpPr>
@@ -10558,7 +10198,7 @@
       </p:sp>
       <p:sp>
         <p:nvSpPr>
-          <p:cNvPr id="46" name="Shape 44"/>
+          <p:cNvPr id="44" name="Shape 42"/>
           <p:cNvSpPr/>
           <p:nvPr/>
         </p:nvSpPr>
@@ -10583,7 +10223,7 @@
       </p:sp>
       <p:sp>
         <p:nvSpPr>
-          <p:cNvPr id="47" name="Shape 45"/>
+          <p:cNvPr id="45" name="Shape 43"/>
           <p:cNvSpPr/>
           <p:nvPr/>
         </p:nvSpPr>
@@ -10603,7 +10243,7 @@
       </p:sp>
       <p:sp>
         <p:nvSpPr>
-          <p:cNvPr id="48" name="Text 46"/>
+          <p:cNvPr id="46" name="Text 44"/>
           <p:cNvSpPr/>
           <p:nvPr/>
         </p:nvSpPr>
@@ -10642,7 +10282,7 @@
       </p:sp>
       <p:sp>
         <p:nvSpPr>
-          <p:cNvPr id="49" name="Text 47"/>
+          <p:cNvPr id="47" name="Text 45"/>
           <p:cNvSpPr/>
           <p:nvPr/>
         </p:nvSpPr>
@@ -10681,7 +10321,7 @@
       </p:sp>
       <p:sp>
         <p:nvSpPr>
-          <p:cNvPr id="50" name="Text 48"/>
+          <p:cNvPr id="48" name="Text 46"/>
           <p:cNvSpPr/>
           <p:nvPr/>
         </p:nvSpPr>
@@ -10720,7 +10360,7 @@
       </p:sp>
       <p:sp>
         <p:nvSpPr>
-          <p:cNvPr id="51" name="Text 49"/>
+          <p:cNvPr id="49" name="Text 47"/>
           <p:cNvSpPr/>
           <p:nvPr/>
         </p:nvSpPr>
@@ -10759,7 +10399,7 @@
       </p:sp>
       <p:sp>
         <p:nvSpPr>
-          <p:cNvPr id="52" name="Text 50"/>
+          <p:cNvPr id="50" name="Text 48"/>
           <p:cNvSpPr/>
           <p:nvPr/>
         </p:nvSpPr>
@@ -10798,7 +10438,7 @@
       </p:sp>
       <p:sp>
         <p:nvSpPr>
-          <p:cNvPr id="53" name="Shape 51"/>
+          <p:cNvPr id="51" name="Shape 49"/>
           <p:cNvSpPr/>
           <p:nvPr/>
         </p:nvSpPr>
@@ -10823,7 +10463,7 @@
       </p:sp>
       <p:sp>
         <p:nvSpPr>
-          <p:cNvPr id="54" name="Shape 52"/>
+          <p:cNvPr id="52" name="Shape 50"/>
           <p:cNvSpPr/>
           <p:nvPr/>
         </p:nvSpPr>
@@ -10843,7 +10483,7 @@
       </p:sp>
       <p:sp>
         <p:nvSpPr>
-          <p:cNvPr id="55" name="Text 53"/>
+          <p:cNvPr id="53" name="Text 51"/>
           <p:cNvSpPr/>
           <p:nvPr/>
         </p:nvSpPr>
@@ -10882,7 +10522,7 @@
       </p:sp>
       <p:sp>
         <p:nvSpPr>
-          <p:cNvPr id="56" name="Text 54"/>
+          <p:cNvPr id="54" name="Text 52"/>
           <p:cNvSpPr/>
           <p:nvPr/>
         </p:nvSpPr>
@@ -10921,7 +10561,7 @@
       </p:sp>
       <p:sp>
         <p:nvSpPr>
-          <p:cNvPr id="57" name="Text 55"/>
+          <p:cNvPr id="55" name="Text 53"/>
           <p:cNvSpPr/>
           <p:nvPr/>
         </p:nvSpPr>
@@ -10960,7 +10600,7 @@
       </p:sp>
       <p:sp>
         <p:nvSpPr>
-          <p:cNvPr id="58" name="Text 56"/>
+          <p:cNvPr id="56" name="Text 54"/>
           <p:cNvSpPr/>
           <p:nvPr/>
         </p:nvSpPr>
@@ -10999,7 +10639,7 @@
       </p:sp>
       <p:sp>
         <p:nvSpPr>
-          <p:cNvPr id="59" name="Text 57"/>
+          <p:cNvPr id="57" name="Text 55"/>
           <p:cNvSpPr/>
           <p:nvPr/>
         </p:nvSpPr>
@@ -11038,7 +10678,7 @@
       </p:sp>
       <p:sp>
         <p:nvSpPr>
-          <p:cNvPr id="60" name="Shape 58"/>
+          <p:cNvPr id="58" name="Shape 56"/>
           <p:cNvSpPr/>
           <p:nvPr/>
         </p:nvSpPr>
@@ -11063,7 +10703,7 @@
       </p:sp>
       <p:sp>
         <p:nvSpPr>
-          <p:cNvPr id="61" name="Text 59"/>
+          <p:cNvPr id="59" name="Text 57"/>
           <p:cNvSpPr/>
           <p:nvPr/>
         </p:nvSpPr>
@@ -11102,7 +10742,7 @@
       </p:sp>
       <p:sp>
         <p:nvSpPr>
-          <p:cNvPr id="62" name="Text 60"/>
+          <p:cNvPr id="60" name="Text 58"/>
           <p:cNvSpPr/>
           <p:nvPr/>
         </p:nvSpPr>
@@ -11141,7 +10781,7 @@
       </p:sp>
       <p:sp>
         <p:nvSpPr>
-          <p:cNvPr id="63" name="Text 61"/>
+          <p:cNvPr id="61" name="Text 59"/>
           <p:cNvSpPr/>
           <p:nvPr/>
         </p:nvSpPr>
@@ -11180,7 +10820,7 @@
       </p:sp>
       <p:sp>
         <p:nvSpPr>
-          <p:cNvPr id="64" name="Text 62"/>
+          <p:cNvPr id="62" name="Text 60"/>
           <p:cNvSpPr/>
           <p:nvPr/>
         </p:nvSpPr>
@@ -11219,7 +10859,7 @@
       </p:sp>
       <p:sp>
         <p:nvSpPr>
-          <p:cNvPr id="65" name="Text 63"/>
+          <p:cNvPr id="63" name="Text 61"/>
           <p:cNvSpPr/>
           <p:nvPr/>
         </p:nvSpPr>
@@ -11258,7 +10898,7 @@
       </p:sp>
       <p:sp>
         <p:nvSpPr>
-          <p:cNvPr id="66" name="Shape 64"/>
+          <p:cNvPr id="64" name="Shape 62"/>
           <p:cNvSpPr/>
           <p:nvPr/>
         </p:nvSpPr>
@@ -11278,7 +10918,7 @@
       </p:sp>
       <p:sp>
         <p:nvSpPr>
-          <p:cNvPr id="67" name="Text 65"/>
+          <p:cNvPr id="65" name="Text 63"/>
           <p:cNvSpPr/>
           <p:nvPr/>
         </p:nvSpPr>
@@ -11317,7 +10957,7 @@
       </p:sp>
       <p:sp>
         <p:nvSpPr>
-          <p:cNvPr id="68" name="Shape 66"/>
+          <p:cNvPr id="66" name="Shape 64"/>
           <p:cNvSpPr/>
           <p:nvPr/>
         </p:nvSpPr>
@@ -11337,7 +10977,7 @@
       </p:sp>
       <p:sp>
         <p:nvSpPr>
-          <p:cNvPr id="69" name="Text 67"/>
+          <p:cNvPr id="67" name="Text 65"/>
           <p:cNvSpPr/>
           <p:nvPr/>
         </p:nvSpPr>
@@ -11408,47 +11048,7 @@
       </p:grpSpPr>
       <p:sp>
         <p:nvSpPr>
-          <p:cNvPr id="2" name="Shape 0"/>
-          <p:cNvSpPr/>
-          <p:nvPr/>
-        </p:nvSpPr>
-        <p:spPr>
-          <a:xfrm>
-            <a:off x="0" y="0"/>
-            <a:ext cx="9144000" cy="137160"/>
-          </a:xfrm>
-          <a:prstGeom prst="rect">
-            <a:avLst/>
-          </a:prstGeom>
-          <a:solidFill>
-            <a:srgbClr val="FF9E16"/>
-          </a:solidFill>
-          <a:ln/>
-        </p:spPr>
-      </p:sp>
-      <p:sp>
-        <p:nvSpPr>
-          <p:cNvPr id="3" name="Shape 1"/>
-          <p:cNvSpPr/>
-          <p:nvPr/>
-        </p:nvSpPr>
-        <p:spPr>
-          <a:xfrm>
-            <a:off x="0" y="0"/>
-            <a:ext cx="164592" cy="5143500"/>
-          </a:xfrm>
-          <a:prstGeom prst="rect">
-            <a:avLst/>
-          </a:prstGeom>
-          <a:solidFill>
-            <a:srgbClr val="009EDF"/>
-          </a:solidFill>
-          <a:ln/>
-        </p:spPr>
-      </p:sp>
-      <p:sp>
-        <p:nvSpPr>
-          <p:cNvPr id="4" name="Text 2"/>
+          <p:cNvPr id="2" name="Text 0"/>
           <p:cNvSpPr/>
           <p:nvPr/>
         </p:nvSpPr>
@@ -11487,7 +11087,7 @@
       </p:sp>
       <p:sp>
         <p:nvSpPr>
-          <p:cNvPr id="5" name="Shape 3"/>
+          <p:cNvPr id="3" name="Shape 1"/>
           <p:cNvSpPr/>
           <p:nvPr/>
         </p:nvSpPr>
@@ -11507,7 +11107,7 @@
       </p:sp>
       <p:sp>
         <p:nvSpPr>
-          <p:cNvPr id="6" name="Text 4"/>
+          <p:cNvPr id="4" name="Text 2"/>
           <p:cNvSpPr/>
           <p:nvPr/>
         </p:nvSpPr>
@@ -11546,7 +11146,7 @@
       </p:sp>
       <p:sp>
         <p:nvSpPr>
-          <p:cNvPr id="7" name="Shape 5"/>
+          <p:cNvPr id="5" name="Shape 3"/>
           <p:cNvSpPr/>
           <p:nvPr/>
         </p:nvSpPr>
@@ -11578,7 +11178,7 @@
       </p:sp>
       <p:sp>
         <p:nvSpPr>
-          <p:cNvPr id="8" name="Shape 6"/>
+          <p:cNvPr id="6" name="Shape 4"/>
           <p:cNvSpPr/>
           <p:nvPr/>
         </p:nvSpPr>
@@ -11598,7 +11198,7 @@
       </p:sp>
       <p:sp>
         <p:nvSpPr>
-          <p:cNvPr id="9" name="Text 7"/>
+          <p:cNvPr id="7" name="Text 5"/>
           <p:cNvSpPr/>
           <p:nvPr/>
         </p:nvSpPr>
@@ -11637,7 +11237,7 @@
       </p:sp>
       <p:sp>
         <p:nvSpPr>
-          <p:cNvPr id="10" name="Text 8"/>
+          <p:cNvPr id="8" name="Text 6"/>
           <p:cNvSpPr/>
           <p:nvPr/>
         </p:nvSpPr>
@@ -11676,7 +11276,7 @@
       </p:sp>
       <p:sp>
         <p:nvSpPr>
-          <p:cNvPr id="11" name="Shape 9"/>
+          <p:cNvPr id="9" name="Shape 7"/>
           <p:cNvSpPr/>
           <p:nvPr/>
         </p:nvSpPr>
@@ -11696,7 +11296,7 @@
       </p:sp>
       <p:sp>
         <p:nvSpPr>
-          <p:cNvPr id="12" name="Shape 10"/>
+          <p:cNvPr id="10" name="Shape 8"/>
           <p:cNvSpPr/>
           <p:nvPr/>
         </p:nvSpPr>
@@ -11716,7 +11316,7 @@
       </p:sp>
       <p:sp>
         <p:nvSpPr>
-          <p:cNvPr id="13" name="Text 11"/>
+          <p:cNvPr id="11" name="Text 9"/>
           <p:cNvSpPr/>
           <p:nvPr/>
         </p:nvSpPr>
@@ -11755,7 +11355,7 @@
       </p:sp>
       <p:sp>
         <p:nvSpPr>
-          <p:cNvPr id="14" name="Text 12"/>
+          <p:cNvPr id="12" name="Text 10"/>
           <p:cNvSpPr/>
           <p:nvPr/>
         </p:nvSpPr>
@@ -11794,7 +11394,7 @@
       </p:sp>
       <p:sp>
         <p:nvSpPr>
-          <p:cNvPr id="15" name="Shape 13"/>
+          <p:cNvPr id="13" name="Shape 11"/>
           <p:cNvSpPr/>
           <p:nvPr/>
         </p:nvSpPr>
@@ -11814,7 +11414,7 @@
       </p:sp>
       <p:sp>
         <p:nvSpPr>
-          <p:cNvPr id="16" name="Shape 14"/>
+          <p:cNvPr id="14" name="Shape 12"/>
           <p:cNvSpPr/>
           <p:nvPr/>
         </p:nvSpPr>
@@ -11834,7 +11434,7 @@
       </p:sp>
       <p:sp>
         <p:nvSpPr>
-          <p:cNvPr id="17" name="Text 15"/>
+          <p:cNvPr id="15" name="Text 13"/>
           <p:cNvSpPr/>
           <p:nvPr/>
         </p:nvSpPr>
@@ -11873,7 +11473,7 @@
       </p:sp>
       <p:sp>
         <p:nvSpPr>
-          <p:cNvPr id="18" name="Text 16"/>
+          <p:cNvPr id="16" name="Text 14"/>
           <p:cNvSpPr/>
           <p:nvPr/>
         </p:nvSpPr>
@@ -11912,7 +11512,7 @@
       </p:sp>
       <p:sp>
         <p:nvSpPr>
-          <p:cNvPr id="19" name="Shape 17"/>
+          <p:cNvPr id="17" name="Shape 15"/>
           <p:cNvSpPr/>
           <p:nvPr/>
         </p:nvSpPr>
@@ -11932,7 +11532,7 @@
       </p:sp>
       <p:sp>
         <p:nvSpPr>
-          <p:cNvPr id="20" name="Shape 18"/>
+          <p:cNvPr id="18" name="Shape 16"/>
           <p:cNvSpPr/>
           <p:nvPr/>
         </p:nvSpPr>
@@ -11952,7 +11552,7 @@
       </p:sp>
       <p:sp>
         <p:nvSpPr>
-          <p:cNvPr id="21" name="Text 19"/>
+          <p:cNvPr id="19" name="Text 17"/>
           <p:cNvSpPr/>
           <p:nvPr/>
         </p:nvSpPr>
@@ -11991,7 +11591,7 @@
       </p:sp>
       <p:sp>
         <p:nvSpPr>
-          <p:cNvPr id="22" name="Text 20"/>
+          <p:cNvPr id="20" name="Text 18"/>
           <p:cNvSpPr/>
           <p:nvPr/>
         </p:nvSpPr>
@@ -12030,7 +11630,7 @@
       </p:sp>
       <p:sp>
         <p:nvSpPr>
-          <p:cNvPr id="23" name="Shape 21"/>
+          <p:cNvPr id="21" name="Shape 19"/>
           <p:cNvSpPr/>
           <p:nvPr/>
         </p:nvSpPr>
@@ -12050,7 +11650,7 @@
       </p:sp>
       <p:sp>
         <p:nvSpPr>
-          <p:cNvPr id="24" name="Shape 22"/>
+          <p:cNvPr id="22" name="Shape 20"/>
           <p:cNvSpPr/>
           <p:nvPr/>
         </p:nvSpPr>
@@ -12070,7 +11670,7 @@
       </p:sp>
       <p:sp>
         <p:nvSpPr>
-          <p:cNvPr id="25" name="Text 23"/>
+          <p:cNvPr id="23" name="Text 21"/>
           <p:cNvSpPr/>
           <p:nvPr/>
         </p:nvSpPr>
@@ -12109,7 +11709,7 @@
       </p:sp>
       <p:sp>
         <p:nvSpPr>
-          <p:cNvPr id="26" name="Text 24"/>
+          <p:cNvPr id="24" name="Text 22"/>
           <p:cNvSpPr/>
           <p:nvPr/>
         </p:nvSpPr>
@@ -12148,7 +11748,7 @@
       </p:sp>
       <p:sp>
         <p:nvSpPr>
-          <p:cNvPr id="27" name="Shape 25"/>
+          <p:cNvPr id="25" name="Shape 23"/>
           <p:cNvSpPr/>
           <p:nvPr/>
         </p:nvSpPr>
@@ -12168,7 +11768,7 @@
       </p:sp>
       <p:sp>
         <p:nvSpPr>
-          <p:cNvPr id="28" name="Shape 26"/>
+          <p:cNvPr id="26" name="Shape 24"/>
           <p:cNvSpPr/>
           <p:nvPr/>
         </p:nvSpPr>
@@ -12188,7 +11788,7 @@
       </p:sp>
       <p:sp>
         <p:nvSpPr>
-          <p:cNvPr id="29" name="Text 27"/>
+          <p:cNvPr id="27" name="Text 25"/>
           <p:cNvSpPr/>
           <p:nvPr/>
         </p:nvSpPr>
@@ -12227,7 +11827,7 @@
       </p:sp>
       <p:sp>
         <p:nvSpPr>
-          <p:cNvPr id="30" name="Text 28"/>
+          <p:cNvPr id="28" name="Text 26"/>
           <p:cNvSpPr/>
           <p:nvPr/>
         </p:nvSpPr>
@@ -12266,7 +11866,7 @@
       </p:sp>
       <p:sp>
         <p:nvSpPr>
-          <p:cNvPr id="31" name="Shape 29"/>
+          <p:cNvPr id="29" name="Shape 27"/>
           <p:cNvSpPr/>
           <p:nvPr/>
         </p:nvSpPr>
@@ -12286,7 +11886,7 @@
       </p:sp>
       <p:sp>
         <p:nvSpPr>
-          <p:cNvPr id="32" name="Shape 30"/>
+          <p:cNvPr id="30" name="Shape 28"/>
           <p:cNvSpPr/>
           <p:nvPr/>
         </p:nvSpPr>
@@ -12306,7 +11906,7 @@
       </p:sp>
       <p:sp>
         <p:nvSpPr>
-          <p:cNvPr id="33" name="Text 31"/>
+          <p:cNvPr id="31" name="Text 29"/>
           <p:cNvSpPr/>
           <p:nvPr/>
         </p:nvSpPr>
@@ -12345,7 +11945,7 @@
       </p:sp>
       <p:sp>
         <p:nvSpPr>
-          <p:cNvPr id="34" name="Text 32"/>
+          <p:cNvPr id="32" name="Text 30"/>
           <p:cNvSpPr/>
           <p:nvPr/>
         </p:nvSpPr>
@@ -12384,7 +11984,7 @@
       </p:sp>
       <p:sp>
         <p:nvSpPr>
-          <p:cNvPr id="35" name="Shape 33"/>
+          <p:cNvPr id="33" name="Shape 31"/>
           <p:cNvSpPr/>
           <p:nvPr/>
         </p:nvSpPr>
@@ -12416,7 +12016,7 @@
       </p:sp>
       <p:sp>
         <p:nvSpPr>
-          <p:cNvPr id="36" name="Shape 34"/>
+          <p:cNvPr id="34" name="Shape 32"/>
           <p:cNvSpPr/>
           <p:nvPr/>
         </p:nvSpPr>
@@ -12436,7 +12036,7 @@
       </p:sp>
       <p:sp>
         <p:nvSpPr>
-          <p:cNvPr id="37" name="Text 35"/>
+          <p:cNvPr id="35" name="Text 33"/>
           <p:cNvSpPr/>
           <p:nvPr/>
         </p:nvSpPr>
@@ -12475,7 +12075,7 @@
       </p:sp>
       <p:sp>
         <p:nvSpPr>
-          <p:cNvPr id="38" name="Text 36"/>
+          <p:cNvPr id="36" name="Text 34"/>
           <p:cNvSpPr/>
           <p:nvPr/>
         </p:nvSpPr>
@@ -12514,7 +12114,7 @@
       </p:sp>
       <p:sp>
         <p:nvSpPr>
-          <p:cNvPr id="39" name="Shape 37"/>
+          <p:cNvPr id="37" name="Shape 35"/>
           <p:cNvSpPr/>
           <p:nvPr/>
         </p:nvSpPr>
@@ -12539,7 +12139,7 @@
       </p:sp>
       <p:sp>
         <p:nvSpPr>
-          <p:cNvPr id="40" name="Shape 38"/>
+          <p:cNvPr id="38" name="Shape 36"/>
           <p:cNvSpPr/>
           <p:nvPr/>
         </p:nvSpPr>
@@ -12559,7 +12159,7 @@
       </p:sp>
       <p:sp>
         <p:nvSpPr>
-          <p:cNvPr id="41" name="Text 39"/>
+          <p:cNvPr id="39" name="Text 37"/>
           <p:cNvSpPr/>
           <p:nvPr/>
         </p:nvSpPr>
@@ -12598,7 +12198,7 @@
       </p:sp>
       <p:sp>
         <p:nvSpPr>
-          <p:cNvPr id="42" name="Text 40"/>
+          <p:cNvPr id="40" name="Text 38"/>
           <p:cNvSpPr/>
           <p:nvPr/>
         </p:nvSpPr>
@@ -12637,7 +12237,7 @@
       </p:sp>
       <p:sp>
         <p:nvSpPr>
-          <p:cNvPr id="43" name="Text 41"/>
+          <p:cNvPr id="41" name="Text 39"/>
           <p:cNvSpPr/>
           <p:nvPr/>
         </p:nvSpPr>
@@ -12676,7 +12276,7 @@
       </p:sp>
       <p:sp>
         <p:nvSpPr>
-          <p:cNvPr id="44" name="Text 42"/>
+          <p:cNvPr id="42" name="Text 40"/>
           <p:cNvSpPr/>
           <p:nvPr/>
         </p:nvSpPr>
@@ -12715,7 +12315,7 @@
       </p:sp>
       <p:sp>
         <p:nvSpPr>
-          <p:cNvPr id="45" name="Shape 43"/>
+          <p:cNvPr id="43" name="Shape 41"/>
           <p:cNvSpPr/>
           <p:nvPr/>
         </p:nvSpPr>
@@ -12740,7 +12340,7 @@
       </p:sp>
       <p:sp>
         <p:nvSpPr>
-          <p:cNvPr id="46" name="Shape 44"/>
+          <p:cNvPr id="44" name="Shape 42"/>
           <p:cNvSpPr/>
           <p:nvPr/>
         </p:nvSpPr>
@@ -12760,7 +12360,7 @@
       </p:sp>
       <p:sp>
         <p:nvSpPr>
-          <p:cNvPr id="47" name="Text 45"/>
+          <p:cNvPr id="45" name="Text 43"/>
           <p:cNvSpPr/>
           <p:nvPr/>
         </p:nvSpPr>
@@ -12799,7 +12399,7 @@
       </p:sp>
       <p:sp>
         <p:nvSpPr>
-          <p:cNvPr id="48" name="Text 46"/>
+          <p:cNvPr id="46" name="Text 44"/>
           <p:cNvSpPr/>
           <p:nvPr/>
         </p:nvSpPr>
@@ -12838,7 +12438,7 @@
       </p:sp>
       <p:sp>
         <p:nvSpPr>
-          <p:cNvPr id="49" name="Text 47"/>
+          <p:cNvPr id="47" name="Text 45"/>
           <p:cNvSpPr/>
           <p:nvPr/>
         </p:nvSpPr>
@@ -12877,7 +12477,7 @@
       </p:sp>
       <p:sp>
         <p:nvSpPr>
-          <p:cNvPr id="50" name="Text 48"/>
+          <p:cNvPr id="48" name="Text 46"/>
           <p:cNvSpPr/>
           <p:nvPr/>
         </p:nvSpPr>
@@ -12916,7 +12516,7 @@
       </p:sp>
       <p:sp>
         <p:nvSpPr>
-          <p:cNvPr id="51" name="Shape 49"/>
+          <p:cNvPr id="49" name="Shape 47"/>
           <p:cNvSpPr/>
           <p:nvPr/>
         </p:nvSpPr>
@@ -12941,7 +12541,7 @@
       </p:sp>
       <p:sp>
         <p:nvSpPr>
-          <p:cNvPr id="52" name="Shape 50"/>
+          <p:cNvPr id="50" name="Shape 48"/>
           <p:cNvSpPr/>
           <p:nvPr/>
         </p:nvSpPr>
@@ -12961,7 +12561,7 @@
       </p:sp>
       <p:sp>
         <p:nvSpPr>
-          <p:cNvPr id="53" name="Text 51"/>
+          <p:cNvPr id="51" name="Text 49"/>
           <p:cNvSpPr/>
           <p:nvPr/>
         </p:nvSpPr>
@@ -13000,7 +12600,7 @@
       </p:sp>
       <p:sp>
         <p:nvSpPr>
-          <p:cNvPr id="54" name="Text 52"/>
+          <p:cNvPr id="52" name="Text 50"/>
           <p:cNvSpPr/>
           <p:nvPr/>
         </p:nvSpPr>
@@ -13039,7 +12639,7 @@
       </p:sp>
       <p:sp>
         <p:nvSpPr>
-          <p:cNvPr id="55" name="Text 53"/>
+          <p:cNvPr id="53" name="Text 51"/>
           <p:cNvSpPr/>
           <p:nvPr/>
         </p:nvSpPr>
@@ -13110,47 +12710,7 @@
       </p:grpSpPr>
       <p:sp>
         <p:nvSpPr>
-          <p:cNvPr id="2" name="Shape 0"/>
-          <p:cNvSpPr/>
-          <p:nvPr/>
-        </p:nvSpPr>
-        <p:spPr>
-          <a:xfrm>
-            <a:off x="0" y="0"/>
-            <a:ext cx="9144000" cy="137160"/>
-          </a:xfrm>
-          <a:prstGeom prst="rect">
-            <a:avLst/>
-          </a:prstGeom>
-          <a:solidFill>
-            <a:srgbClr val="FF9E16"/>
-          </a:solidFill>
-          <a:ln/>
-        </p:spPr>
-      </p:sp>
-      <p:sp>
-        <p:nvSpPr>
-          <p:cNvPr id="3" name="Shape 1"/>
-          <p:cNvSpPr/>
-          <p:nvPr/>
-        </p:nvSpPr>
-        <p:spPr>
-          <a:xfrm>
-            <a:off x="0" y="0"/>
-            <a:ext cx="164592" cy="5143500"/>
-          </a:xfrm>
-          <a:prstGeom prst="rect">
-            <a:avLst/>
-          </a:prstGeom>
-          <a:solidFill>
-            <a:srgbClr val="009EDF"/>
-          </a:solidFill>
-          <a:ln/>
-        </p:spPr>
-      </p:sp>
-      <p:sp>
-        <p:nvSpPr>
-          <p:cNvPr id="4" name="Text 2"/>
+          <p:cNvPr id="2" name="Text 0"/>
           <p:cNvSpPr/>
           <p:nvPr/>
         </p:nvSpPr>
@@ -13189,7 +12749,7 @@
       </p:sp>
       <p:sp>
         <p:nvSpPr>
-          <p:cNvPr id="5" name="Shape 3"/>
+          <p:cNvPr id="3" name="Shape 1"/>
           <p:cNvSpPr/>
           <p:nvPr/>
         </p:nvSpPr>
@@ -13209,7 +12769,7 @@
       </p:sp>
       <p:sp>
         <p:nvSpPr>
-          <p:cNvPr id="6" name="Shape 4"/>
+          <p:cNvPr id="4" name="Shape 2"/>
           <p:cNvSpPr/>
           <p:nvPr/>
         </p:nvSpPr>
@@ -13241,7 +12801,7 @@
       </p:sp>
       <p:sp>
         <p:nvSpPr>
-          <p:cNvPr id="7" name="Shape 5"/>
+          <p:cNvPr id="5" name="Shape 3"/>
           <p:cNvSpPr/>
           <p:nvPr/>
         </p:nvSpPr>
@@ -13261,7 +12821,7 @@
       </p:sp>
       <p:sp>
         <p:nvSpPr>
-          <p:cNvPr id="8" name="Text 6"/>
+          <p:cNvPr id="6" name="Text 4"/>
           <p:cNvSpPr/>
           <p:nvPr/>
         </p:nvSpPr>
@@ -13300,7 +12860,7 @@
       </p:sp>
       <p:sp>
         <p:nvSpPr>
-          <p:cNvPr id="9" name="Shape 7"/>
+          <p:cNvPr id="7" name="Shape 5"/>
           <p:cNvSpPr/>
           <p:nvPr/>
         </p:nvSpPr>
@@ -13320,7 +12880,7 @@
       </p:sp>
       <p:sp>
         <p:nvSpPr>
-          <p:cNvPr id="10" name="Text 8"/>
+          <p:cNvPr id="8" name="Text 6"/>
           <p:cNvSpPr/>
           <p:nvPr/>
         </p:nvSpPr>
@@ -13359,7 +12919,7 @@
       </p:sp>
       <p:sp>
         <p:nvSpPr>
-          <p:cNvPr id="11" name="Shape 9"/>
+          <p:cNvPr id="9" name="Shape 7"/>
           <p:cNvSpPr/>
           <p:nvPr/>
         </p:nvSpPr>
@@ -13379,7 +12939,7 @@
       </p:sp>
       <p:sp>
         <p:nvSpPr>
-          <p:cNvPr id="12" name="Text 10"/>
+          <p:cNvPr id="10" name="Text 8"/>
           <p:cNvSpPr/>
           <p:nvPr/>
         </p:nvSpPr>
@@ -13418,7 +12978,7 @@
       </p:sp>
       <p:sp>
         <p:nvSpPr>
-          <p:cNvPr id="13" name="Shape 11"/>
+          <p:cNvPr id="11" name="Shape 9"/>
           <p:cNvSpPr/>
           <p:nvPr/>
         </p:nvSpPr>
@@ -13438,7 +12998,7 @@
       </p:sp>
       <p:sp>
         <p:nvSpPr>
-          <p:cNvPr id="14" name="Text 12"/>
+          <p:cNvPr id="12" name="Text 10"/>
           <p:cNvSpPr/>
           <p:nvPr/>
         </p:nvSpPr>
@@ -13477,7 +13037,7 @@
       </p:sp>
       <p:sp>
         <p:nvSpPr>
-          <p:cNvPr id="15" name="Shape 13"/>
+          <p:cNvPr id="13" name="Shape 11"/>
           <p:cNvSpPr/>
           <p:nvPr/>
         </p:nvSpPr>
@@ -13500,7 +13060,7 @@
       </p:sp>
       <p:sp>
         <p:nvSpPr>
-          <p:cNvPr id="16" name="Shape 14"/>
+          <p:cNvPr id="14" name="Shape 12"/>
           <p:cNvSpPr/>
           <p:nvPr/>
         </p:nvSpPr>
@@ -13523,7 +13083,7 @@
       </p:sp>
       <p:sp>
         <p:nvSpPr>
-          <p:cNvPr id="17" name="Shape 15"/>
+          <p:cNvPr id="15" name="Shape 13"/>
           <p:cNvSpPr/>
           <p:nvPr/>
         </p:nvSpPr>
@@ -13546,7 +13106,7 @@
       </p:sp>
       <p:sp>
         <p:nvSpPr>
-          <p:cNvPr id="18" name="Shape 16"/>
+          <p:cNvPr id="16" name="Shape 14"/>
           <p:cNvSpPr/>
           <p:nvPr/>
         </p:nvSpPr>
@@ -13569,7 +13129,7 @@
       </p:sp>
       <p:sp>
         <p:nvSpPr>
-          <p:cNvPr id="19" name="Shape 17"/>
+          <p:cNvPr id="17" name="Shape 15"/>
           <p:cNvSpPr/>
           <p:nvPr/>
         </p:nvSpPr>
@@ -13592,7 +13152,7 @@
       </p:sp>
       <p:sp>
         <p:nvSpPr>
-          <p:cNvPr id="20" name="Shape 18"/>
+          <p:cNvPr id="18" name="Shape 16"/>
           <p:cNvSpPr/>
           <p:nvPr/>
         </p:nvSpPr>
@@ -13615,7 +13175,7 @@
       </p:sp>
       <p:sp>
         <p:nvSpPr>
-          <p:cNvPr id="21" name="Shape 19"/>
+          <p:cNvPr id="19" name="Shape 17"/>
           <p:cNvSpPr/>
           <p:nvPr/>
         </p:nvSpPr>
@@ -13638,7 +13198,7 @@
       </p:sp>
       <p:sp>
         <p:nvSpPr>
-          <p:cNvPr id="22" name="Shape 20"/>
+          <p:cNvPr id="20" name="Shape 18"/>
           <p:cNvSpPr/>
           <p:nvPr/>
         </p:nvSpPr>
@@ -13661,7 +13221,7 @@
       </p:sp>
       <p:sp>
         <p:nvSpPr>
-          <p:cNvPr id="23" name="Shape 21"/>
+          <p:cNvPr id="21" name="Shape 19"/>
           <p:cNvSpPr/>
           <p:nvPr/>
         </p:nvSpPr>
@@ -13684,7 +13244,7 @@
       </p:sp>
       <p:sp>
         <p:nvSpPr>
-          <p:cNvPr id="24" name="Shape 22"/>
+          <p:cNvPr id="22" name="Shape 20"/>
           <p:cNvSpPr/>
           <p:nvPr/>
         </p:nvSpPr>
@@ -13707,7 +13267,7 @@
       </p:sp>
       <p:sp>
         <p:nvSpPr>
-          <p:cNvPr id="25" name="Shape 23"/>
+          <p:cNvPr id="23" name="Shape 21"/>
           <p:cNvSpPr/>
           <p:nvPr/>
         </p:nvSpPr>
@@ -13730,7 +13290,7 @@
       </p:sp>
       <p:sp>
         <p:nvSpPr>
-          <p:cNvPr id="26" name="Shape 24"/>
+          <p:cNvPr id="24" name="Shape 22"/>
           <p:cNvSpPr/>
           <p:nvPr/>
         </p:nvSpPr>
@@ -13753,7 +13313,7 @@
       </p:sp>
       <p:sp>
         <p:nvSpPr>
-          <p:cNvPr id="27" name="Shape 25"/>
+          <p:cNvPr id="25" name="Shape 23"/>
           <p:cNvSpPr/>
           <p:nvPr/>
         </p:nvSpPr>
@@ -13778,7 +13338,7 @@
       </p:sp>
       <p:sp>
         <p:nvSpPr>
-          <p:cNvPr id="28" name="Shape 26"/>
+          <p:cNvPr id="26" name="Shape 24"/>
           <p:cNvSpPr/>
           <p:nvPr/>
         </p:nvSpPr>
@@ -13798,7 +13358,7 @@
       </p:sp>
       <p:sp>
         <p:nvSpPr>
-          <p:cNvPr id="29" name="Text 27"/>
+          <p:cNvPr id="27" name="Text 25"/>
           <p:cNvSpPr/>
           <p:nvPr/>
         </p:nvSpPr>
@@ -13837,7 +13397,7 @@
       </p:sp>
       <p:sp>
         <p:nvSpPr>
-          <p:cNvPr id="30" name="Shape 28"/>
+          <p:cNvPr id="28" name="Shape 26"/>
           <p:cNvSpPr/>
           <p:nvPr/>
         </p:nvSpPr>
@@ -13857,7 +13417,7 @@
       </p:sp>
       <p:sp>
         <p:nvSpPr>
-          <p:cNvPr id="31" name="Shape 29"/>
+          <p:cNvPr id="29" name="Shape 27"/>
           <p:cNvSpPr/>
           <p:nvPr/>
         </p:nvSpPr>
@@ -13877,7 +13437,7 @@
       </p:sp>
       <p:sp>
         <p:nvSpPr>
-          <p:cNvPr id="32" name="Text 30"/>
+          <p:cNvPr id="30" name="Text 28"/>
           <p:cNvSpPr/>
           <p:nvPr/>
         </p:nvSpPr>
@@ -13916,7 +13476,7 @@
       </p:sp>
       <p:sp>
         <p:nvSpPr>
-          <p:cNvPr id="33" name="Shape 31"/>
+          <p:cNvPr id="31" name="Shape 29"/>
           <p:cNvSpPr/>
           <p:nvPr/>
         </p:nvSpPr>
@@ -13941,7 +13501,7 @@
       </p:sp>
       <p:sp>
         <p:nvSpPr>
-          <p:cNvPr id="34" name="Shape 32"/>
+          <p:cNvPr id="32" name="Shape 30"/>
           <p:cNvSpPr/>
           <p:nvPr/>
         </p:nvSpPr>
@@ -13961,7 +13521,7 @@
       </p:sp>
       <p:sp>
         <p:nvSpPr>
-          <p:cNvPr id="35" name="Text 33"/>
+          <p:cNvPr id="33" name="Text 31"/>
           <p:cNvSpPr/>
           <p:nvPr/>
         </p:nvSpPr>
@@ -14000,7 +13560,7 @@
       </p:sp>
       <p:sp>
         <p:nvSpPr>
-          <p:cNvPr id="36" name="Shape 34"/>
+          <p:cNvPr id="34" name="Shape 32"/>
           <p:cNvSpPr/>
           <p:nvPr/>
         </p:nvSpPr>
@@ -14020,7 +13580,7 @@
       </p:sp>
       <p:sp>
         <p:nvSpPr>
-          <p:cNvPr id="37" name="Shape 35"/>
+          <p:cNvPr id="35" name="Shape 33"/>
           <p:cNvSpPr/>
           <p:nvPr/>
         </p:nvSpPr>
@@ -14040,7 +13600,7 @@
       </p:sp>
       <p:sp>
         <p:nvSpPr>
-          <p:cNvPr id="38" name="Text 36"/>
+          <p:cNvPr id="36" name="Text 34"/>
           <p:cNvSpPr/>
           <p:nvPr/>
         </p:nvSpPr>
@@ -14079,7 +13639,7 @@
       </p:sp>
       <p:sp>
         <p:nvSpPr>
-          <p:cNvPr id="39" name="Shape 37"/>
+          <p:cNvPr id="37" name="Shape 35"/>
           <p:cNvSpPr/>
           <p:nvPr/>
         </p:nvSpPr>
@@ -14104,7 +13664,7 @@
       </p:sp>
       <p:sp>
         <p:nvSpPr>
-          <p:cNvPr id="40" name="Shape 38"/>
+          <p:cNvPr id="38" name="Shape 36"/>
           <p:cNvSpPr/>
           <p:nvPr/>
         </p:nvSpPr>
@@ -14124,7 +13684,7 @@
       </p:sp>
       <p:sp>
         <p:nvSpPr>
-          <p:cNvPr id="41" name="Text 39"/>
+          <p:cNvPr id="39" name="Text 37"/>
           <p:cNvSpPr/>
           <p:nvPr/>
         </p:nvSpPr>
@@ -14163,7 +13723,7 @@
       </p:sp>
       <p:sp>
         <p:nvSpPr>
-          <p:cNvPr id="42" name="Shape 40"/>
+          <p:cNvPr id="40" name="Shape 38"/>
           <p:cNvSpPr/>
           <p:nvPr/>
         </p:nvSpPr>
@@ -14183,7 +13743,7 @@
       </p:sp>
       <p:sp>
         <p:nvSpPr>
-          <p:cNvPr id="43" name="Shape 41"/>
+          <p:cNvPr id="41" name="Shape 39"/>
           <p:cNvSpPr/>
           <p:nvPr/>
         </p:nvSpPr>
@@ -14203,7 +13763,7 @@
       </p:sp>
       <p:sp>
         <p:nvSpPr>
-          <p:cNvPr id="44" name="Text 42"/>
+          <p:cNvPr id="42" name="Text 40"/>
           <p:cNvSpPr/>
           <p:nvPr/>
         </p:nvSpPr>
@@ -14242,7 +13802,7 @@
       </p:sp>
       <p:sp>
         <p:nvSpPr>
-          <p:cNvPr id="45" name="Shape 43"/>
+          <p:cNvPr id="43" name="Shape 41"/>
           <p:cNvSpPr/>
           <p:nvPr/>
         </p:nvSpPr>
@@ -14267,7 +13827,7 @@
       </p:sp>
       <p:sp>
         <p:nvSpPr>
-          <p:cNvPr id="46" name="Shape 44"/>
+          <p:cNvPr id="44" name="Shape 42"/>
           <p:cNvSpPr/>
           <p:nvPr/>
         </p:nvSpPr>
@@ -14287,7 +13847,7 @@
       </p:sp>
       <p:sp>
         <p:nvSpPr>
-          <p:cNvPr id="47" name="Text 45"/>
+          <p:cNvPr id="45" name="Text 43"/>
           <p:cNvSpPr/>
           <p:nvPr/>
         </p:nvSpPr>
@@ -14326,7 +13886,7 @@
       </p:sp>
       <p:sp>
         <p:nvSpPr>
-          <p:cNvPr id="48" name="Shape 46"/>
+          <p:cNvPr id="46" name="Shape 44"/>
           <p:cNvSpPr/>
           <p:nvPr/>
         </p:nvSpPr>
@@ -14346,7 +13906,7 @@
       </p:sp>
       <p:sp>
         <p:nvSpPr>
-          <p:cNvPr id="49" name="Shape 47"/>
+          <p:cNvPr id="47" name="Shape 45"/>
           <p:cNvSpPr/>
           <p:nvPr/>
         </p:nvSpPr>
@@ -14366,7 +13926,7 @@
       </p:sp>
       <p:sp>
         <p:nvSpPr>
-          <p:cNvPr id="50" name="Text 48"/>
+          <p:cNvPr id="48" name="Text 46"/>
           <p:cNvSpPr/>
           <p:nvPr/>
         </p:nvSpPr>
@@ -14405,7 +13965,7 @@
       </p:sp>
       <p:sp>
         <p:nvSpPr>
-          <p:cNvPr id="51" name="Shape 49"/>
+          <p:cNvPr id="49" name="Shape 47"/>
           <p:cNvSpPr/>
           <p:nvPr/>
         </p:nvSpPr>
@@ -14430,7 +13990,7 @@
       </p:sp>
       <p:sp>
         <p:nvSpPr>
-          <p:cNvPr id="52" name="Shape 50"/>
+          <p:cNvPr id="50" name="Shape 48"/>
           <p:cNvSpPr/>
           <p:nvPr/>
         </p:nvSpPr>
@@ -14450,7 +14010,7 @@
       </p:sp>
       <p:sp>
         <p:nvSpPr>
-          <p:cNvPr id="53" name="Text 51"/>
+          <p:cNvPr id="51" name="Text 49"/>
           <p:cNvSpPr/>
           <p:nvPr/>
         </p:nvSpPr>
@@ -14489,7 +14049,7 @@
       </p:sp>
       <p:sp>
         <p:nvSpPr>
-          <p:cNvPr id="54" name="Shape 52"/>
+          <p:cNvPr id="52" name="Shape 50"/>
           <p:cNvSpPr/>
           <p:nvPr/>
         </p:nvSpPr>
@@ -14509,7 +14069,7 @@
       </p:sp>
       <p:sp>
         <p:nvSpPr>
-          <p:cNvPr id="55" name="Shape 53"/>
+          <p:cNvPr id="53" name="Shape 51"/>
           <p:cNvSpPr/>
           <p:nvPr/>
         </p:nvSpPr>
@@ -14529,7 +14089,7 @@
       </p:sp>
       <p:sp>
         <p:nvSpPr>
-          <p:cNvPr id="56" name="Text 54"/>
+          <p:cNvPr id="54" name="Text 52"/>
           <p:cNvSpPr/>
           <p:nvPr/>
         </p:nvSpPr>
@@ -14568,7 +14128,7 @@
       </p:sp>
       <p:sp>
         <p:nvSpPr>
-          <p:cNvPr id="57" name="Shape 55"/>
+          <p:cNvPr id="55" name="Shape 53"/>
           <p:cNvSpPr/>
           <p:nvPr/>
         </p:nvSpPr>
@@ -14593,7 +14153,7 @@
       </p:sp>
       <p:sp>
         <p:nvSpPr>
-          <p:cNvPr id="58" name="Shape 56"/>
+          <p:cNvPr id="56" name="Shape 54"/>
           <p:cNvSpPr/>
           <p:nvPr/>
         </p:nvSpPr>
@@ -14613,7 +14173,7 @@
       </p:sp>
       <p:sp>
         <p:nvSpPr>
-          <p:cNvPr id="59" name="Text 57"/>
+          <p:cNvPr id="57" name="Text 55"/>
           <p:cNvSpPr/>
           <p:nvPr/>
         </p:nvSpPr>
@@ -14652,7 +14212,7 @@
       </p:sp>
       <p:sp>
         <p:nvSpPr>
-          <p:cNvPr id="60" name="Shape 58"/>
+          <p:cNvPr id="58" name="Shape 56"/>
           <p:cNvSpPr/>
           <p:nvPr/>
         </p:nvSpPr>
@@ -14672,7 +14232,7 @@
       </p:sp>
       <p:sp>
         <p:nvSpPr>
-          <p:cNvPr id="61" name="Shape 59"/>
+          <p:cNvPr id="59" name="Shape 57"/>
           <p:cNvSpPr/>
           <p:nvPr/>
         </p:nvSpPr>
@@ -14692,7 +14252,7 @@
       </p:sp>
       <p:sp>
         <p:nvSpPr>
-          <p:cNvPr id="62" name="Text 60"/>
+          <p:cNvPr id="60" name="Text 58"/>
           <p:cNvSpPr/>
           <p:nvPr/>
         </p:nvSpPr>
@@ -14731,7 +14291,7 @@
       </p:sp>
       <p:sp>
         <p:nvSpPr>
-          <p:cNvPr id="63" name="Shape 61"/>
+          <p:cNvPr id="61" name="Shape 59"/>
           <p:cNvSpPr/>
           <p:nvPr/>
         </p:nvSpPr>
@@ -14756,7 +14316,7 @@
       </p:sp>
       <p:sp>
         <p:nvSpPr>
-          <p:cNvPr id="64" name="Shape 62"/>
+          <p:cNvPr id="62" name="Shape 60"/>
           <p:cNvSpPr/>
           <p:nvPr/>
         </p:nvSpPr>
@@ -14776,7 +14336,7 @@
       </p:sp>
       <p:sp>
         <p:nvSpPr>
-          <p:cNvPr id="65" name="Text 63"/>
+          <p:cNvPr id="63" name="Text 61"/>
           <p:cNvSpPr/>
           <p:nvPr/>
         </p:nvSpPr>
@@ -14815,7 +14375,7 @@
       </p:sp>
       <p:sp>
         <p:nvSpPr>
-          <p:cNvPr id="66" name="Shape 64"/>
+          <p:cNvPr id="64" name="Shape 62"/>
           <p:cNvSpPr/>
           <p:nvPr/>
         </p:nvSpPr>
@@ -14835,7 +14395,7 @@
       </p:sp>
       <p:sp>
         <p:nvSpPr>
-          <p:cNvPr id="67" name="Shape 65"/>
+          <p:cNvPr id="65" name="Shape 63"/>
           <p:cNvSpPr/>
           <p:nvPr/>
         </p:nvSpPr>
@@ -14855,7 +14415,7 @@
       </p:sp>
       <p:sp>
         <p:nvSpPr>
-          <p:cNvPr id="68" name="Text 66"/>
+          <p:cNvPr id="66" name="Text 64"/>
           <p:cNvSpPr/>
           <p:nvPr/>
         </p:nvSpPr>
@@ -14894,7 +14454,7 @@
       </p:sp>
       <p:sp>
         <p:nvSpPr>
-          <p:cNvPr id="69" name="Text 67"/>
+          <p:cNvPr id="67" name="Text 65"/>
           <p:cNvSpPr/>
           <p:nvPr/>
         </p:nvSpPr>

</xml_diff>